<commit_message>
Improve digital strategy PPT rendering
</commit_message>
<xml_diff>
--- a/AriaAI/skills/digital-strategy/assets/Template.pptx
+++ b/AriaAI/skills/digital-strategy/assets/Template.pptx
@@ -5,17 +5,19 @@
     <p:sldMasterId id="2147483648" r:id="rId1"/>
   </p:sldMasterIdLst>
   <p:notesMasterIdLst>
-    <p:notesMasterId r:id="rId5"/>
+    <p:notesMasterId r:id="rId7"/>
   </p:notesMasterIdLst>
   <p:sldIdLst>
     <p:sldId id="256" r:id="rId2"/>
     <p:sldId id="295" r:id="rId3"/>
-    <p:sldId id="294" r:id="rId4"/>
+    <p:sldId id="296" r:id="rId4"/>
+    <p:sldId id="297" r:id="rId5"/>
+    <p:sldId id="294" r:id="rId6"/>
   </p:sldIdLst>
   <p:sldSz cx="12192000" cy="6858000"/>
   <p:notesSz cx="6858000" cy="9144000"/>
   <p:custDataLst>
-    <p:tags r:id="rId6"/>
+    <p:tags r:id="rId8"/>
   </p:custDataLst>
   <p:defaultTextStyle>
     <a:defPPr>
@@ -229,7 +231,7 @@
             <a:fld id="{E39D9A20-47A0-4507-821D-C8B61CB79B2C}" type="datetimeFigureOut">
               <a:rPr lang="en-GB" smtClean="0"/>
               <a:pPr/>
-              <a:t>28/03/2026</a:t>
+              <a:t>22/04/2026</a:t>
             </a:fld>
             <a:endParaRPr lang="en-GB" dirty="0"/>
           </a:p>
@@ -602,49 +604,7 @@
       </p:pic>
       <p:sp>
         <p:nvSpPr>
-          <p:cNvPr id="2" name="Title 1"/>
-          <p:cNvSpPr>
-            <a:spLocks noGrp="1"/>
-          </p:cNvSpPr>
-          <p:nvPr>
-            <p:ph type="ctrTitle" hasCustomPrompt="1"/>
-          </p:nvPr>
-        </p:nvSpPr>
-        <p:spPr>
-          <a:xfrm>
-            <a:off x="1274841" y="1764699"/>
-            <a:ext cx="5765982" cy="2903488"/>
-          </a:xfrm>
-          <a:prstGeom prst="rect">
-            <a:avLst/>
-          </a:prstGeom>
-          <a:noFill/>
-          <a:ln>
-            <a:noFill/>
-          </a:ln>
-        </p:spPr>
-        <p:txBody>
-          <a:bodyPr lIns="0" tIns="0" rIns="0" bIns="0" anchor="ctr" anchorCtr="0"/>
-          <a:lstStyle>
-            <a:lvl1pPr lvl="0" algn="l">
-              <a:defRPr sz="6600" baseline="0">
-                <a:solidFill>
-                  <a:schemeClr val="bg1"/>
-                </a:solidFill>
-              </a:defRPr>
-            </a:lvl1pPr>
-          </a:lstStyle>
-          <a:p>
-            <a:r>
-              <a:rPr lang="en-US" altLang="en-US"/>
-              <a:t>Title slide text only</a:t>
-            </a:r>
-          </a:p>
-        </p:txBody>
-      </p:sp>
-      <p:sp>
-        <p:nvSpPr>
-          <p:cNvPr id="6" name="Text Placeholder 3"/>
+          <p:cNvPr id="6" name="aria_cover_subtitle"/>
           <p:cNvSpPr>
             <a:spLocks noGrp="1"/>
           </p:cNvSpPr>
@@ -715,15 +675,57 @@
           <a:p>
             <a:pPr lvl="0"/>
             <a:r>
-              <a:rPr lang="en-US" altLang="en-US"/>
+              <a:rPr lang="en-US" altLang="en-US" dirty="0"/>
               <a:t>Click to edit Master text styles</a:t>
             </a:r>
           </a:p>
           <a:p>
             <a:pPr lvl="1"/>
             <a:r>
-              <a:rPr lang="en-US" altLang="en-US"/>
+              <a:rPr lang="en-US" altLang="en-US" dirty="0"/>
               <a:t>Second level</a:t>
+            </a:r>
+          </a:p>
+        </p:txBody>
+      </p:sp>
+      <p:sp>
+        <p:nvSpPr>
+          <p:cNvPr id="2" name="aria_cover_title"/>
+          <p:cNvSpPr>
+            <a:spLocks noGrp="1"/>
+          </p:cNvSpPr>
+          <p:nvPr>
+            <p:ph type="ctrTitle" hasCustomPrompt="1"/>
+          </p:nvPr>
+        </p:nvSpPr>
+        <p:spPr>
+          <a:xfrm>
+            <a:off x="1274841" y="1764699"/>
+            <a:ext cx="5765982" cy="2903488"/>
+          </a:xfrm>
+          <a:prstGeom prst="rect">
+            <a:avLst/>
+          </a:prstGeom>
+          <a:noFill/>
+          <a:ln>
+            <a:noFill/>
+          </a:ln>
+        </p:spPr>
+        <p:txBody>
+          <a:bodyPr lIns="0" tIns="0" rIns="0" bIns="0" anchor="ctr" anchorCtr="0"/>
+          <a:lstStyle>
+            <a:lvl1pPr lvl="0" algn="l">
+              <a:defRPr sz="6600" baseline="0">
+                <a:solidFill>
+                  <a:schemeClr val="bg1"/>
+                </a:solidFill>
+              </a:defRPr>
+            </a:lvl1pPr>
+          </a:lstStyle>
+          <a:p>
+            <a:r>
+              <a:rPr lang="en-US" altLang="en-US" dirty="0"/>
+              <a:t>Title slide text only</a:t>
             </a:r>
           </a:p>
         </p:txBody>
@@ -777,7 +779,7 @@
       </p:grpSpPr>
       <p:sp>
         <p:nvSpPr>
-          <p:cNvPr id="9" name="Text Placeholder 8"/>
+          <p:cNvPr id="9" name="aria_slide_body"/>
           <p:cNvSpPr>
             <a:spLocks noGrp="1"/>
           </p:cNvSpPr>
@@ -834,7 +836,7 @@
       </p:sp>
       <p:sp>
         <p:nvSpPr>
-          <p:cNvPr id="2" name="Title 1">
+          <p:cNvPr id="2" name="aria_slide_title">
             <a:extLst>
               <a:ext uri="{FF2B5EF4-FFF2-40B4-BE49-F238E27FC236}">
                 <a16:creationId xmlns:a16="http://schemas.microsoft.com/office/drawing/2014/main" id="{8CCFC99C-7410-4D22-BA8D-48877FCFB6C0}"/>
@@ -875,6 +877,311 @@
 </file>
 
 <file path=ppt/slideLayouts/slideLayout3.xml><?xml version="1.0" encoding="utf-8"?>
+<p:sldLayout xmlns:a="http://schemas.openxmlformats.org/drawingml/2006/main" xmlns:r="http://schemas.openxmlformats.org/officeDocument/2006/relationships" xmlns:p="http://schemas.openxmlformats.org/presentationml/2006/main" preserve="1" userDrawn="1">
+  <p:cSld name="1_One Column Text">
+    <p:spTree>
+      <p:nvGrpSpPr>
+        <p:cNvPr id="1" name=""/>
+        <p:cNvGrpSpPr/>
+        <p:nvPr/>
+      </p:nvGrpSpPr>
+      <p:grpSpPr>
+        <a:xfrm>
+          <a:off x="0" y="0"/>
+          <a:ext cx="0" cy="0"/>
+          <a:chOff x="0" y="0"/>
+          <a:chExt cx="0" cy="0"/>
+        </a:xfrm>
+      </p:grpSpPr>
+      <p:sp>
+        <p:nvSpPr>
+          <p:cNvPr id="3" name="aria_right_body">
+            <a:extLst>
+              <a:ext uri="{FF2B5EF4-FFF2-40B4-BE49-F238E27FC236}">
+                <a16:creationId xmlns:a16="http://schemas.microsoft.com/office/drawing/2014/main" id="{58A339FD-473E-A772-84E4-CB4D677DD648}"/>
+              </a:ext>
+            </a:extLst>
+          </p:cNvPr>
+          <p:cNvSpPr>
+            <a:spLocks noGrp="1"/>
+          </p:cNvSpPr>
+          <p:nvPr>
+            <p:ph type="body" sz="quarter" idx="11"/>
+          </p:nvPr>
+        </p:nvSpPr>
+        <p:spPr>
+          <a:xfrm>
+            <a:off x="6481763" y="1330126"/>
+            <a:ext cx="5268277" cy="4546799"/>
+          </a:xfrm>
+        </p:spPr>
+        <p:txBody>
+          <a:bodyPr/>
+          <a:lstStyle/>
+          <a:p>
+            <a:pPr lvl="0"/>
+            <a:r>
+              <a:rPr lang="en-US"/>
+              <a:t>Click to edit Master text styles</a:t>
+            </a:r>
+          </a:p>
+          <a:p>
+            <a:pPr lvl="1"/>
+            <a:r>
+              <a:rPr lang="en-US"/>
+              <a:t>Second level</a:t>
+            </a:r>
+          </a:p>
+          <a:p>
+            <a:pPr lvl="2"/>
+            <a:r>
+              <a:rPr lang="en-US"/>
+              <a:t>Third level</a:t>
+            </a:r>
+          </a:p>
+          <a:p>
+            <a:pPr lvl="3"/>
+            <a:r>
+              <a:rPr lang="en-US"/>
+              <a:t>Fourth level</a:t>
+            </a:r>
+          </a:p>
+          <a:p>
+            <a:pPr lvl="4"/>
+            <a:r>
+              <a:rPr lang="en-US"/>
+              <a:t>Fifth level</a:t>
+            </a:r>
+            <a:endParaRPr lang="en-GB"/>
+          </a:p>
+        </p:txBody>
+      </p:sp>
+      <p:sp>
+        <p:nvSpPr>
+          <p:cNvPr id="9" name="aria_left_body"/>
+          <p:cNvSpPr>
+            <a:spLocks noGrp="1"/>
+          </p:cNvSpPr>
+          <p:nvPr>
+            <p:ph type="body" sz="quarter" idx="10"/>
+          </p:nvPr>
+        </p:nvSpPr>
+        <p:spPr>
+          <a:xfrm>
+            <a:off x="995363" y="1330126"/>
+            <a:ext cx="5268277" cy="4546799"/>
+          </a:xfrm>
+        </p:spPr>
+        <p:txBody>
+          <a:bodyPr/>
+          <a:lstStyle/>
+          <a:p>
+            <a:pPr lvl="0"/>
+            <a:r>
+              <a:rPr lang="en-US"/>
+              <a:t>Click to edit Master text styles</a:t>
+            </a:r>
+          </a:p>
+          <a:p>
+            <a:pPr lvl="1"/>
+            <a:r>
+              <a:rPr lang="en-US"/>
+              <a:t>Second level</a:t>
+            </a:r>
+          </a:p>
+          <a:p>
+            <a:pPr lvl="2"/>
+            <a:r>
+              <a:rPr lang="en-US"/>
+              <a:t>Third level</a:t>
+            </a:r>
+          </a:p>
+          <a:p>
+            <a:pPr lvl="3"/>
+            <a:r>
+              <a:rPr lang="en-US"/>
+              <a:t>Fourth level</a:t>
+            </a:r>
+          </a:p>
+          <a:p>
+            <a:pPr lvl="4"/>
+            <a:r>
+              <a:rPr lang="en-US"/>
+              <a:t>Fifth level</a:t>
+            </a:r>
+            <a:endParaRPr lang="en-GB"/>
+          </a:p>
+        </p:txBody>
+      </p:sp>
+      <p:sp>
+        <p:nvSpPr>
+          <p:cNvPr id="2" name="aria_slide_title">
+            <a:extLst>
+              <a:ext uri="{FF2B5EF4-FFF2-40B4-BE49-F238E27FC236}">
+                <a16:creationId xmlns:a16="http://schemas.microsoft.com/office/drawing/2014/main" id="{8CCFC99C-7410-4D22-BA8D-48877FCFB6C0}"/>
+              </a:ext>
+            </a:extLst>
+          </p:cNvPr>
+          <p:cNvSpPr>
+            <a:spLocks noGrp="1"/>
+          </p:cNvSpPr>
+          <p:nvPr>
+            <p:ph type="title"/>
+          </p:nvPr>
+        </p:nvSpPr>
+        <p:spPr>
+          <a:xfrm>
+            <a:off x="995362" y="431800"/>
+            <a:ext cx="10754678" cy="539750"/>
+          </a:xfrm>
+        </p:spPr>
+        <p:txBody>
+          <a:bodyPr/>
+          <a:lstStyle/>
+          <a:p>
+            <a:r>
+              <a:rPr lang="en-US"/>
+              <a:t>Click to edit Master title style</a:t>
+            </a:r>
+            <a:endParaRPr lang="en-GB"/>
+          </a:p>
+        </p:txBody>
+      </p:sp>
+    </p:spTree>
+    <p:extLst>
+      <p:ext uri="{BB962C8B-B14F-4D97-AF65-F5344CB8AC3E}">
+        <p14:creationId xmlns:p14="http://schemas.microsoft.com/office/powerpoint/2010/main" val="1198907668"/>
+      </p:ext>
+    </p:extLst>
+  </p:cSld>
+  <p:clrMapOvr>
+    <a:masterClrMapping/>
+  </p:clrMapOvr>
+</p:sldLayout>
+</file>
+
+<file path=ppt/slideLayouts/slideLayout4.xml><?xml version="1.0" encoding="utf-8"?>
+<p:sldLayout xmlns:a="http://schemas.openxmlformats.org/drawingml/2006/main" xmlns:r="http://schemas.openxmlformats.org/officeDocument/2006/relationships" xmlns:p="http://schemas.openxmlformats.org/presentationml/2006/main" preserve="1" userDrawn="1">
+  <p:cSld name="2_One Column Text">
+    <p:spTree>
+      <p:nvGrpSpPr>
+        <p:cNvPr id="1" name=""/>
+        <p:cNvGrpSpPr/>
+        <p:nvPr/>
+      </p:nvGrpSpPr>
+      <p:grpSpPr>
+        <a:xfrm>
+          <a:off x="0" y="0"/>
+          <a:ext cx="0" cy="0"/>
+          <a:chOff x="0" y="0"/>
+          <a:chExt cx="0" cy="0"/>
+        </a:xfrm>
+      </p:grpSpPr>
+      <p:sp>
+        <p:nvSpPr>
+          <p:cNvPr id="9" name="aria_slide_body"/>
+          <p:cNvSpPr>
+            <a:spLocks noGrp="1"/>
+          </p:cNvSpPr>
+          <p:nvPr>
+            <p:ph type="body" sz="quarter" idx="10"/>
+          </p:nvPr>
+        </p:nvSpPr>
+        <p:spPr>
+          <a:xfrm>
+            <a:off x="995363" y="1330126"/>
+            <a:ext cx="5268277" cy="4546799"/>
+          </a:xfrm>
+        </p:spPr>
+        <p:txBody>
+          <a:bodyPr/>
+          <a:lstStyle/>
+          <a:p>
+            <a:pPr lvl="0"/>
+            <a:r>
+              <a:rPr lang="en-US"/>
+              <a:t>Click to edit Master text styles</a:t>
+            </a:r>
+          </a:p>
+          <a:p>
+            <a:pPr lvl="1"/>
+            <a:r>
+              <a:rPr lang="en-US"/>
+              <a:t>Second level</a:t>
+            </a:r>
+          </a:p>
+          <a:p>
+            <a:pPr lvl="2"/>
+            <a:r>
+              <a:rPr lang="en-US"/>
+              <a:t>Third level</a:t>
+            </a:r>
+          </a:p>
+          <a:p>
+            <a:pPr lvl="3"/>
+            <a:r>
+              <a:rPr lang="en-US"/>
+              <a:t>Fourth level</a:t>
+            </a:r>
+          </a:p>
+          <a:p>
+            <a:pPr lvl="4"/>
+            <a:r>
+              <a:rPr lang="en-US"/>
+              <a:t>Fifth level</a:t>
+            </a:r>
+            <a:endParaRPr lang="en-GB"/>
+          </a:p>
+        </p:txBody>
+      </p:sp>
+      <p:sp>
+        <p:nvSpPr>
+          <p:cNvPr id="2" name="aria_slide_title">
+            <a:extLst>
+              <a:ext uri="{FF2B5EF4-FFF2-40B4-BE49-F238E27FC236}">
+                <a16:creationId xmlns:a16="http://schemas.microsoft.com/office/drawing/2014/main" id="{8CCFC99C-7410-4D22-BA8D-48877FCFB6C0}"/>
+              </a:ext>
+            </a:extLst>
+          </p:cNvPr>
+          <p:cNvSpPr>
+            <a:spLocks noGrp="1"/>
+          </p:cNvSpPr>
+          <p:nvPr>
+            <p:ph type="title"/>
+          </p:nvPr>
+        </p:nvSpPr>
+        <p:spPr>
+          <a:xfrm>
+            <a:off x="995362" y="431800"/>
+            <a:ext cx="10754678" cy="539750"/>
+          </a:xfrm>
+        </p:spPr>
+        <p:txBody>
+          <a:bodyPr/>
+          <a:lstStyle/>
+          <a:p>
+            <a:r>
+              <a:rPr lang="en-US"/>
+              <a:t>Click to edit Master title style</a:t>
+            </a:r>
+            <a:endParaRPr lang="en-GB"/>
+          </a:p>
+        </p:txBody>
+      </p:sp>
+    </p:spTree>
+    <p:extLst>
+      <p:ext uri="{BB962C8B-B14F-4D97-AF65-F5344CB8AC3E}">
+        <p14:creationId xmlns:p14="http://schemas.microsoft.com/office/powerpoint/2010/main" val="47051943"/>
+      </p:ext>
+    </p:extLst>
+  </p:cSld>
+  <p:clrMapOvr>
+    <a:masterClrMapping/>
+  </p:clrMapOvr>
+</p:sldLayout>
+</file>
+
+<file path=ppt/slideLayouts/slideLayout5.xml><?xml version="1.0" encoding="utf-8"?>
 <p:sldLayout xmlns:a="http://schemas.openxmlformats.org/drawingml/2006/main" xmlns:r="http://schemas.openxmlformats.org/officeDocument/2006/relationships" xmlns:p="http://schemas.openxmlformats.org/presentationml/2006/main" showMasterSp="0">
   <p:cSld name="2_Back Cover dark Gradient">
     <p:bg>
@@ -2512,7 +2819,7 @@
           </p:cNvGraphicFramePr>
           <p:nvPr userDrawn="1">
             <p:custDataLst>
-              <p:tags r:id="rId5"/>
+              <p:tags r:id="rId7"/>
             </p:custDataLst>
             <p:extLst>
               <p:ext uri="{D42A27DB-BD31-4B8C-83A1-F6EECF244321}">
@@ -2529,12 +2836,12 @@
           <a:graphicData uri="http://schemas.openxmlformats.org/presentationml/2006/ole">
             <mc:AlternateContent xmlns:mc="http://schemas.openxmlformats.org/markup-compatibility/2006">
               <mc:Choice xmlns:v="urn:schemas-microsoft-com:vml" Requires="v">
-                <p:oleObj name="think-cell Slide" r:id="rId7" imgW="592" imgH="591" progId="TCLayout.ActiveDocument.1">
+                <p:oleObj name="think-cell Slide" r:id="rId9" imgW="592" imgH="591" progId="TCLayout.ActiveDocument.1">
                   <p:embed/>
                 </p:oleObj>
               </mc:Choice>
               <mc:Fallback>
-                <p:oleObj name="think-cell Slide" r:id="rId7" imgW="592" imgH="591" progId="TCLayout.ActiveDocument.1">
+                <p:oleObj name="think-cell Slide" r:id="rId9" imgW="592" imgH="591" progId="TCLayout.ActiveDocument.1">
                   <p:embed/>
                   <p:pic>
                     <p:nvPicPr>
@@ -2545,7 +2852,7 @@
                       <p:nvPr/>
                     </p:nvPicPr>
                     <p:blipFill>
-                      <a:blip r:embed="rId8"/>
+                      <a:blip r:embed="rId10"/>
                       <a:stretch/>
                     </p:blipFill>
                     <p:spPr>
@@ -2619,36 +2926,77 @@
           <a:p>
             <a:pPr lvl="0"/>
             <a:r>
-              <a:rPr lang="nl-NL" altLang="nl-NL"/>
-              <a:t>Click to edit Master text styles</a:t>
+              <a:rPr lang="nl-NL" altLang="nl-NL" dirty="0"/>
+              <a:t>Click </a:t>
             </a:r>
+            <a:r>
+              <a:rPr lang="nl-NL" altLang="nl-NL" dirty="0" err="1"/>
+              <a:t>to</a:t>
+            </a:r>
+            <a:r>
+              <a:rPr lang="nl-NL" altLang="nl-NL" dirty="0"/>
+              <a:t> </a:t>
+            </a:r>
+            <a:r>
+              <a:rPr lang="nl-NL" altLang="nl-NL" dirty="0" err="1"/>
+              <a:t>edit</a:t>
+            </a:r>
+            <a:r>
+              <a:rPr lang="nl-NL" altLang="nl-NL" dirty="0"/>
+              <a:t> Master </a:t>
+            </a:r>
+            <a:r>
+              <a:rPr lang="nl-NL" altLang="nl-NL" dirty="0" err="1"/>
+              <a:t>text</a:t>
+            </a:r>
+            <a:r>
+              <a:rPr lang="nl-NL" altLang="nl-NL" dirty="0"/>
+              <a:t> </a:t>
+            </a:r>
+            <a:r>
+              <a:rPr lang="nl-NL" altLang="nl-NL" dirty="0" err="1"/>
+              <a:t>styles</a:t>
+            </a:r>
+            <a:endParaRPr lang="nl-NL" altLang="nl-NL" dirty="0"/>
           </a:p>
           <a:p>
             <a:pPr lvl="1"/>
             <a:r>
-              <a:rPr lang="nl-NL" altLang="nl-NL"/>
+              <a:rPr lang="nl-NL" altLang="nl-NL" dirty="0"/>
               <a:t>Second level</a:t>
             </a:r>
           </a:p>
           <a:p>
             <a:pPr lvl="2"/>
             <a:r>
-              <a:rPr lang="nl-NL" altLang="nl-NL"/>
-              <a:t>Third level</a:t>
+              <a:rPr lang="nl-NL" altLang="nl-NL" dirty="0" err="1"/>
+              <a:t>Third</a:t>
+            </a:r>
+            <a:r>
+              <a:rPr lang="nl-NL" altLang="nl-NL" dirty="0"/>
+              <a:t> level</a:t>
             </a:r>
           </a:p>
           <a:p>
             <a:pPr lvl="3"/>
             <a:r>
-              <a:rPr lang="nl-NL" altLang="nl-NL"/>
-              <a:t>Fourth level</a:t>
+              <a:rPr lang="nl-NL" altLang="nl-NL" dirty="0" err="1"/>
+              <a:t>Fourth</a:t>
+            </a:r>
+            <a:r>
+              <a:rPr lang="nl-NL" altLang="nl-NL" dirty="0"/>
+              <a:t> level</a:t>
             </a:r>
           </a:p>
           <a:p>
             <a:pPr lvl="4"/>
             <a:r>
-              <a:rPr lang="nl-NL" altLang="nl-NL"/>
-              <a:t>Fifth level</a:t>
+              <a:rPr lang="nl-NL" altLang="nl-NL" dirty="0" err="1"/>
+              <a:t>Fifth</a:t>
+            </a:r>
+            <a:r>
+              <a:rPr lang="nl-NL" altLang="nl-NL" dirty="0"/>
+              <a:t> level</a:t>
             </a:r>
           </a:p>
         </p:txBody>
@@ -2798,7 +3146,7 @@
           <p:cNvSpPr txBox="1"/>
           <p:nvPr userDrawn="1">
             <p:custDataLst>
-              <p:tags r:id="rId6"/>
+              <p:tags r:id="rId8"/>
             </p:custDataLst>
           </p:nvPr>
         </p:nvSpPr>
@@ -2897,7 +3245,7 @@
               <a:defRPr/>
             </a:pPr>
             <a:r>
-              <a:rPr lang="en-US" altLang="en-US" sz="600">
+              <a:rPr lang="en-US" altLang="en-US" sz="600" dirty="0">
                 <a:solidFill>
                   <a:schemeClr val="bg1">
                     <a:lumMod val="65000"/>
@@ -2907,7 +3255,59 @@
                 <a:latin typeface="Arial"/>
                 <a:ea typeface="DengXian"/>
               </a:rPr>
-              <a:t>© 2025 KPMG Advisory (China) Limited, a limited liability company in Mainland China and a member firm of the KPMG global organisation of independent member firms affiliated with KPMG International Limited, a private English company limited by guarantee. All rights reserved. Printed in Mainland China.</a:t>
+              <a:t>© 202</a:t>
+            </a:r>
+            <a:r>
+              <a:rPr lang="en-US" altLang="zh-CN" sz="600" dirty="0">
+                <a:solidFill>
+                  <a:schemeClr val="bg1">
+                    <a:lumMod val="65000"/>
+                  </a:schemeClr>
+                </a:solidFill>
+                <a:effectLst/>
+                <a:latin typeface="Arial"/>
+                <a:ea typeface="DengXian"/>
+              </a:rPr>
+              <a:t>6</a:t>
+            </a:r>
+            <a:r>
+              <a:rPr lang="en-US" altLang="en-US" sz="600" dirty="0">
+                <a:solidFill>
+                  <a:schemeClr val="bg1">
+                    <a:lumMod val="65000"/>
+                  </a:schemeClr>
+                </a:solidFill>
+                <a:effectLst/>
+                <a:latin typeface="Arial"/>
+                <a:ea typeface="DengXian"/>
+              </a:rPr>
+              <a:t> KPMG Advisory (China) Limited, a limited liability company in Mainland China and a member firm of the KPMG global </a:t>
+            </a:r>
+            <a:r>
+              <a:rPr lang="en-US" altLang="en-US" sz="600" dirty="0" err="1">
+                <a:solidFill>
+                  <a:schemeClr val="bg1">
+                    <a:lumMod val="65000"/>
+                  </a:schemeClr>
+                </a:solidFill>
+                <a:effectLst/>
+                <a:latin typeface="Arial"/>
+                <a:ea typeface="DengXian"/>
+              </a:rPr>
+              <a:t>organisation</a:t>
+            </a:r>
+            <a:r>
+              <a:rPr lang="en-US" altLang="en-US" sz="600" dirty="0">
+                <a:solidFill>
+                  <a:schemeClr val="bg1">
+                    <a:lumMod val="65000"/>
+                  </a:schemeClr>
+                </a:solidFill>
+                <a:effectLst/>
+                <a:latin typeface="Arial"/>
+                <a:ea typeface="DengXian"/>
+              </a:rPr>
+              <a:t> of independent member firms affiliated with KPMG International Limited, a private English company limited by guarantee. All rights reserved. Printed in Mainland China.</a:t>
             </a:r>
           </a:p>
         </p:txBody>
@@ -4003,7 +4403,9 @@
   <p:sldLayoutIdLst>
     <p:sldLayoutId id="2147483649" r:id="rId1"/>
     <p:sldLayoutId id="2147483724" r:id="rId2"/>
-    <p:sldLayoutId id="2147483656" r:id="rId3"/>
+    <p:sldLayoutId id="2147483725" r:id="rId3"/>
+    <p:sldLayoutId id="2147483726" r:id="rId4"/>
+    <p:sldLayoutId id="2147483656" r:id="rId5"/>
   </p:sldLayoutIdLst>
   <p:txStyles>
     <p:titleStyle>
@@ -4341,129 +4743,6 @@
           <a:chExt cx="0" cy="0"/>
         </a:xfrm>
       </p:grpSpPr>
-      <p:sp>
-        <p:nvSpPr>
-          <p:cNvPr id="16" name="Title 3">
-            <a:extLst>
-              <a:ext uri="{FF2B5EF4-FFF2-40B4-BE49-F238E27FC236}">
-                <a16:creationId xmlns:a16="http://schemas.microsoft.com/office/drawing/2014/main" id="{7E0DB666-ECE0-EB5F-D45A-F0B8E874CD4B}"/>
-              </a:ext>
-            </a:extLst>
-          </p:cNvPr>
-          <p:cNvSpPr txBox="1">
-            <a:spLocks/>
-          </p:cNvSpPr>
-          <p:nvPr/>
-        </p:nvSpPr>
-        <p:spPr>
-          <a:xfrm>
-            <a:off x="995362" y="2189426"/>
-            <a:ext cx="5872364" cy="2413897"/>
-          </a:xfrm>
-          <a:prstGeom prst="rect">
-            <a:avLst/>
-          </a:prstGeom>
-          <a:noFill/>
-          <a:ln>
-            <a:noFill/>
-          </a:ln>
-        </p:spPr>
-        <p:txBody>
-          <a:bodyPr vert="horz" lIns="0" tIns="0" rIns="0" bIns="0" anchor="t" anchorCtr="0"/>
-          <a:lstStyle>
-            <a:lvl1pPr lvl="0" algn="l" defTabSz="914400">
-              <a:lnSpc>
-                <a:spcPct val="70000"/>
-              </a:lnSpc>
-              <a:spcBef>
-                <a:spcPct val="0"/>
-              </a:spcBef>
-              <a:buNone/>
-              <a:defRPr sz="6600" kern="1200" baseline="0">
-                <a:solidFill>
-                  <a:schemeClr val="bg1"/>
-                </a:solidFill>
-                <a:latin typeface="KPMG Bold"/>
-                <a:ea typeface="微软雅黑"/>
-              </a:defRPr>
-            </a:lvl1pPr>
-          </a:lstStyle>
-          <a:p>
-            <a:pPr>
-              <a:lnSpc>
-                <a:spcPct val="100000"/>
-              </a:lnSpc>
-            </a:pPr>
-            <a:r>
-              <a:rPr lang="en-US" altLang="zh-CN" sz="4000" b="1" dirty="0">
-                <a:latin typeface="Microsoft YaHei"/>
-                <a:ea typeface="Microsoft YaHei"/>
-              </a:rPr>
-              <a:t>&lt;</a:t>
-            </a:r>
-            <a:r>
-              <a:rPr lang="zh-CN" altLang="en-US" sz="4000" b="1" dirty="0">
-                <a:latin typeface="Microsoft YaHei"/>
-                <a:ea typeface="Microsoft YaHei"/>
-              </a:rPr>
-              <a:t>客户名称</a:t>
-            </a:r>
-            <a:r>
-              <a:rPr lang="en-US" altLang="zh-CN" sz="4000" b="1" dirty="0">
-                <a:latin typeface="Microsoft YaHei"/>
-                <a:ea typeface="Microsoft YaHei"/>
-              </a:rPr>
-              <a:t>&gt;</a:t>
-            </a:r>
-          </a:p>
-          <a:p>
-            <a:pPr>
-              <a:lnSpc>
-                <a:spcPct val="100000"/>
-              </a:lnSpc>
-            </a:pPr>
-            <a:r>
-              <a:rPr lang="en-US" altLang="zh-CN" sz="4000" b="1" dirty="0">
-                <a:latin typeface="Microsoft YaHei"/>
-                <a:ea typeface="Microsoft YaHei"/>
-              </a:rPr>
-              <a:t>&lt;</a:t>
-            </a:r>
-            <a:r>
-              <a:rPr lang="zh-CN" altLang="en-US" sz="4000" b="1" dirty="0">
-                <a:latin typeface="Microsoft YaHei"/>
-                <a:ea typeface="Microsoft YaHei"/>
-              </a:rPr>
-              <a:t>方案建议名称</a:t>
-            </a:r>
-            <a:r>
-              <a:rPr lang="en-US" altLang="zh-CN" sz="4000" b="1" dirty="0">
-                <a:latin typeface="Microsoft YaHei"/>
-                <a:ea typeface="Microsoft YaHei"/>
-              </a:rPr>
-              <a:t>&gt;</a:t>
-            </a:r>
-          </a:p>
-          <a:p>
-            <a:pPr>
-              <a:lnSpc>
-                <a:spcPct val="100000"/>
-              </a:lnSpc>
-            </a:pPr>
-            <a:r>
-              <a:rPr lang="zh-CN" altLang="en-US" sz="4000" b="1" dirty="0">
-                <a:latin typeface="Microsoft YaHei"/>
-                <a:ea typeface="Microsoft YaHei"/>
-              </a:rPr>
-              <a:t>方案建议书</a:t>
-            </a:r>
-            <a:endParaRPr lang="zh-CN" sz="4000" b="1" dirty="0">
-              <a:latin typeface="Microsoft YaHei"/>
-              <a:ea typeface="Microsoft YaHei"/>
-            </a:endParaRPr>
-          </a:p>
-        </p:txBody>
-      </p:sp>
       <p:sp>
         <p:nvSpPr>
           <p:cNvPr id="21" name="Subtitle 4">
@@ -6027,6 +6306,66 @@
           </a:p>
         </p:txBody>
       </p:sp>
+      <p:sp>
+        <p:nvSpPr>
+          <p:cNvPr id="4" name="aria_cover_subtitle">
+            <a:extLst>
+              <a:ext uri="{FF2B5EF4-FFF2-40B4-BE49-F238E27FC236}">
+                <a16:creationId xmlns:a16="http://schemas.microsoft.com/office/drawing/2014/main" id="{2618C577-EB9F-FE46-DA74-CA5DB33BE3F7}"/>
+              </a:ext>
+            </a:extLst>
+          </p:cNvPr>
+          <p:cNvSpPr>
+            <a:spLocks noGrp="1"/>
+          </p:cNvSpPr>
+          <p:nvPr>
+            <p:ph type="body" idx="11"/>
+          </p:nvPr>
+        </p:nvSpPr>
+        <p:spPr>
+          <a:xfrm>
+            <a:off x="995362" y="4718982"/>
+            <a:ext cx="5765982" cy="816606"/>
+          </a:xfrm>
+        </p:spPr>
+        <p:txBody>
+          <a:bodyPr/>
+          <a:lstStyle/>
+          <a:p>
+            <a:endParaRPr lang="zh-CN" altLang="en-US"/>
+          </a:p>
+        </p:txBody>
+      </p:sp>
+      <p:sp>
+        <p:nvSpPr>
+          <p:cNvPr id="3" name="aria_cover_title">
+            <a:extLst>
+              <a:ext uri="{FF2B5EF4-FFF2-40B4-BE49-F238E27FC236}">
+                <a16:creationId xmlns:a16="http://schemas.microsoft.com/office/drawing/2014/main" id="{CD1ED36A-E929-42E9-E46A-EDC05DE8CE83}"/>
+              </a:ext>
+            </a:extLst>
+          </p:cNvPr>
+          <p:cNvSpPr>
+            <a:spLocks noGrp="1"/>
+          </p:cNvSpPr>
+          <p:nvPr>
+            <p:ph type="ctrTitle"/>
+          </p:nvPr>
+        </p:nvSpPr>
+        <p:spPr>
+          <a:xfrm>
+            <a:off x="995362" y="1731528"/>
+            <a:ext cx="5765982" cy="2903488"/>
+          </a:xfrm>
+        </p:spPr>
+        <p:txBody>
+          <a:bodyPr/>
+          <a:lstStyle/>
+          <a:p>
+            <a:endParaRPr lang="zh-CN" altLang="en-US"/>
+          </a:p>
+        </p:txBody>
+      </p:sp>
     </p:spTree>
     <p:extLst>
       <p:ext uri="{BB962C8B-B14F-4D97-AF65-F5344CB8AC3E}">
@@ -6071,7 +6410,7 @@
       </p:grpSpPr>
       <p:sp>
         <p:nvSpPr>
-          <p:cNvPr id="2" name="Text Placeholder 1">
+          <p:cNvPr id="2" name="aria_slide_body">
             <a:extLst>
               <a:ext uri="{FF2B5EF4-FFF2-40B4-BE49-F238E27FC236}">
                 <a16:creationId xmlns:a16="http://schemas.microsoft.com/office/drawing/2014/main" id="{F19E2D56-A366-F6BF-C2F8-650ACBBA4490}"/>
@@ -6096,7 +6435,7 @@
       </p:sp>
       <p:sp>
         <p:nvSpPr>
-          <p:cNvPr id="3" name="Title 2">
+          <p:cNvPr id="3" name="aria_slide_title">
             <a:extLst>
               <a:ext uri="{FF2B5EF4-FFF2-40B4-BE49-F238E27FC236}">
                 <a16:creationId xmlns:a16="http://schemas.microsoft.com/office/drawing/2014/main" id="{6AFFCBD4-6545-1A00-5994-89869FB3447E}"/>
@@ -6115,7 +6454,7 @@
           <a:bodyPr/>
           <a:lstStyle/>
           <a:p>
-            <a:endParaRPr kumimoji="1" lang="zh-CN" altLang="en-US"/>
+            <a:endParaRPr kumimoji="1" lang="zh-CN" altLang="en-US" dirty="0"/>
           </a:p>
         </p:txBody>
       </p:sp>
@@ -6133,6 +6472,254 @@
 </file>
 
 <file path=ppt/slides/slide3.xml><?xml version="1.0" encoding="utf-8"?>
+<p:sld xmlns:a="http://schemas.openxmlformats.org/drawingml/2006/main" xmlns:r="http://schemas.openxmlformats.org/officeDocument/2006/relationships" xmlns:p="http://schemas.openxmlformats.org/presentationml/2006/main">
+  <p:cSld>
+    <p:spTree>
+      <p:nvGrpSpPr>
+        <p:cNvPr id="1" name=""/>
+        <p:cNvGrpSpPr/>
+        <p:nvPr/>
+      </p:nvGrpSpPr>
+      <p:grpSpPr>
+        <a:xfrm>
+          <a:off x="0" y="0"/>
+          <a:ext cx="0" cy="0"/>
+          <a:chOff x="0" y="0"/>
+          <a:chExt cx="0" cy="0"/>
+        </a:xfrm>
+      </p:grpSpPr>
+      <p:sp>
+        <p:nvSpPr>
+          <p:cNvPr id="6" name="aria_right_body">
+            <a:extLst>
+              <a:ext uri="{FF2B5EF4-FFF2-40B4-BE49-F238E27FC236}">
+                <a16:creationId xmlns:a16="http://schemas.microsoft.com/office/drawing/2014/main" id="{4B906D4A-86A1-2F71-824D-FEE0910E5BF0}"/>
+              </a:ext>
+            </a:extLst>
+          </p:cNvPr>
+          <p:cNvSpPr>
+            <a:spLocks noGrp="1"/>
+          </p:cNvSpPr>
+          <p:nvPr>
+            <p:ph type="body" sz="quarter" idx="11"/>
+          </p:nvPr>
+        </p:nvSpPr>
+        <p:spPr/>
+        <p:txBody>
+          <a:bodyPr/>
+          <a:lstStyle/>
+          <a:p>
+            <a:endParaRPr lang="zh-CN" altLang="en-US"/>
+          </a:p>
+        </p:txBody>
+      </p:sp>
+      <p:sp>
+        <p:nvSpPr>
+          <p:cNvPr id="5" name="aria_left_body">
+            <a:extLst>
+              <a:ext uri="{FF2B5EF4-FFF2-40B4-BE49-F238E27FC236}">
+                <a16:creationId xmlns:a16="http://schemas.microsoft.com/office/drawing/2014/main" id="{87B8EB55-53A1-7EF6-77B6-17108F504F34}"/>
+              </a:ext>
+            </a:extLst>
+          </p:cNvPr>
+          <p:cNvSpPr>
+            <a:spLocks noGrp="1"/>
+          </p:cNvSpPr>
+          <p:nvPr>
+            <p:ph type="body" sz="quarter" idx="10"/>
+          </p:nvPr>
+        </p:nvSpPr>
+        <p:spPr/>
+        <p:txBody>
+          <a:bodyPr/>
+          <a:lstStyle/>
+          <a:p>
+            <a:endParaRPr lang="zh-CN" altLang="en-US"/>
+          </a:p>
+        </p:txBody>
+      </p:sp>
+      <p:sp>
+        <p:nvSpPr>
+          <p:cNvPr id="4" name="aria_slide_title">
+            <a:extLst>
+              <a:ext uri="{FF2B5EF4-FFF2-40B4-BE49-F238E27FC236}">
+                <a16:creationId xmlns:a16="http://schemas.microsoft.com/office/drawing/2014/main" id="{83106FB3-E547-9BF9-4343-767BF2EB21EE}"/>
+              </a:ext>
+            </a:extLst>
+          </p:cNvPr>
+          <p:cNvSpPr>
+            <a:spLocks noGrp="1"/>
+          </p:cNvSpPr>
+          <p:nvPr>
+            <p:ph type="title"/>
+          </p:nvPr>
+        </p:nvSpPr>
+        <p:spPr/>
+        <p:txBody>
+          <a:bodyPr/>
+          <a:lstStyle/>
+          <a:p>
+            <a:endParaRPr lang="zh-CN" altLang="en-US"/>
+          </a:p>
+        </p:txBody>
+      </p:sp>
+    </p:spTree>
+    <p:extLst>
+      <p:ext uri="{BB962C8B-B14F-4D97-AF65-F5344CB8AC3E}">
+        <p14:creationId xmlns:p14="http://schemas.microsoft.com/office/powerpoint/2010/main" val="842893013"/>
+      </p:ext>
+    </p:extLst>
+  </p:cSld>
+  <p:clrMapOvr>
+    <a:masterClrMapping/>
+  </p:clrMapOvr>
+</p:sld>
+</file>
+
+<file path=ppt/slides/slide4.xml><?xml version="1.0" encoding="utf-8"?>
+<p:sld xmlns:a="http://schemas.openxmlformats.org/drawingml/2006/main" xmlns:r="http://schemas.openxmlformats.org/officeDocument/2006/relationships" xmlns:p="http://schemas.openxmlformats.org/presentationml/2006/main">
+  <p:cSld>
+    <p:spTree>
+      <p:nvGrpSpPr>
+        <p:cNvPr id="1" name=""/>
+        <p:cNvGrpSpPr/>
+        <p:nvPr/>
+      </p:nvGrpSpPr>
+      <p:grpSpPr>
+        <a:xfrm>
+          <a:off x="0" y="0"/>
+          <a:ext cx="0" cy="0"/>
+          <a:chOff x="0" y="0"/>
+          <a:chExt cx="0" cy="0"/>
+        </a:xfrm>
+      </p:grpSpPr>
+      <p:sp>
+        <p:nvSpPr>
+          <p:cNvPr id="5" name="aria_slide_body">
+            <a:extLst>
+              <a:ext uri="{FF2B5EF4-FFF2-40B4-BE49-F238E27FC236}">
+                <a16:creationId xmlns:a16="http://schemas.microsoft.com/office/drawing/2014/main" id="{34AB6818-F0E0-1016-AF72-0B8C00508A3E}"/>
+              </a:ext>
+            </a:extLst>
+          </p:cNvPr>
+          <p:cNvSpPr>
+            <a:spLocks noGrp="1"/>
+          </p:cNvSpPr>
+          <p:nvPr>
+            <p:ph type="body" sz="quarter" idx="10"/>
+          </p:nvPr>
+        </p:nvSpPr>
+        <p:spPr/>
+        <p:txBody>
+          <a:bodyPr/>
+          <a:lstStyle/>
+          <a:p>
+            <a:endParaRPr lang="zh-CN" altLang="en-US"/>
+          </a:p>
+        </p:txBody>
+      </p:sp>
+      <p:sp>
+        <p:nvSpPr>
+          <p:cNvPr id="4" name="aria_slide_title">
+            <a:extLst>
+              <a:ext uri="{FF2B5EF4-FFF2-40B4-BE49-F238E27FC236}">
+                <a16:creationId xmlns:a16="http://schemas.microsoft.com/office/drawing/2014/main" id="{463EC1D5-6844-3434-E72C-797803841029}"/>
+              </a:ext>
+            </a:extLst>
+          </p:cNvPr>
+          <p:cNvSpPr>
+            <a:spLocks noGrp="1"/>
+          </p:cNvSpPr>
+          <p:nvPr>
+            <p:ph type="title"/>
+          </p:nvPr>
+        </p:nvSpPr>
+        <p:spPr/>
+        <p:txBody>
+          <a:bodyPr/>
+          <a:lstStyle/>
+          <a:p>
+            <a:endParaRPr lang="zh-CN" altLang="en-US" dirty="0"/>
+          </a:p>
+        </p:txBody>
+      </p:sp>
+      <p:sp>
+        <p:nvSpPr>
+          <p:cNvPr id="6" name="aria_visual_area">
+            <a:extLst>
+              <a:ext uri="{FF2B5EF4-FFF2-40B4-BE49-F238E27FC236}">
+                <a16:creationId xmlns:a16="http://schemas.microsoft.com/office/drawing/2014/main" id="{0F001D15-8E9F-729D-F3D8-89F3AB735796}"/>
+              </a:ext>
+            </a:extLst>
+          </p:cNvPr>
+          <p:cNvSpPr/>
+          <p:nvPr/>
+        </p:nvSpPr>
+        <p:spPr>
+          <a:xfrm>
+            <a:off x="6385560" y="1295400"/>
+            <a:ext cx="5532120" cy="4602480"/>
+          </a:xfrm>
+          <a:prstGeom prst="rect">
+            <a:avLst/>
+          </a:prstGeom>
+          <a:noFill/>
+          <a:ln>
+            <a:solidFill>
+              <a:schemeClr val="bg1">
+                <a:lumMod val="95000"/>
+              </a:schemeClr>
+            </a:solidFill>
+          </a:ln>
+        </p:spPr>
+        <p:style>
+          <a:lnRef idx="2">
+            <a:schemeClr val="accent1">
+              <a:shade val="50000"/>
+            </a:schemeClr>
+          </a:lnRef>
+          <a:fillRef idx="1">
+            <a:schemeClr val="accent1"/>
+          </a:fillRef>
+          <a:effectRef idx="0">
+            <a:schemeClr val="accent1"/>
+          </a:effectRef>
+          <a:fontRef idx="minor">
+            <a:schemeClr val="lt1"/>
+          </a:fontRef>
+        </p:style>
+        <p:txBody>
+          <a:bodyPr rot="0" spcFirstLastPara="0" vertOverflow="overflow" horzOverflow="overflow" vert="horz" wrap="square" lIns="54610" tIns="54610" rIns="54610" bIns="54610" numCol="1" spcCol="0" rtlCol="0" fromWordArt="0" anchor="ctr" anchorCtr="0" forceAA="0" compatLnSpc="1">
+            <a:prstTxWarp prst="textNoShape">
+              <a:avLst/>
+            </a:prstTxWarp>
+            <a:noAutofit/>
+          </a:bodyPr>
+          <a:lstStyle/>
+          <a:p>
+            <a:pPr algn="l"/>
+            <a:endParaRPr kumimoji="1" lang="zh-CN" altLang="en-US" sz="1600" dirty="0">
+              <a:solidFill>
+                <a:schemeClr val="bg1"/>
+              </a:solidFill>
+            </a:endParaRPr>
+          </a:p>
+        </p:txBody>
+      </p:sp>
+    </p:spTree>
+    <p:extLst>
+      <p:ext uri="{BB962C8B-B14F-4D97-AF65-F5344CB8AC3E}">
+        <p14:creationId xmlns:p14="http://schemas.microsoft.com/office/powerpoint/2010/main" val="2268729915"/>
+      </p:ext>
+    </p:extLst>
+  </p:cSld>
+  <p:clrMapOvr>
+    <a:masterClrMapping/>
+  </p:clrMapOvr>
+</p:sld>
+</file>
+
+<file path=ppt/slides/slide5.xml><?xml version="1.0" encoding="utf-8"?>
 <p:sld xmlns:a="http://schemas.openxmlformats.org/drawingml/2006/main" xmlns:r="http://schemas.openxmlformats.org/officeDocument/2006/relationships" xmlns:p="http://schemas.openxmlformats.org/presentationml/2006/main">
   <p:cSld>
     <p:spTree>

</xml_diff>

<commit_message>
Use blank digital strategy PPT template pages
</commit_message>
<xml_diff>
--- a/AriaAI/skills/digital-strategy/assets/Template.pptx
+++ b/AriaAI/skills/digital-strategy/assets/Template.pptx
@@ -5,19 +5,20 @@
     <p:sldMasterId id="2147483648" r:id="rId1"/>
   </p:sldMasterIdLst>
   <p:notesMasterIdLst>
-    <p:notesMasterId r:id="rId7"/>
+    <p:notesMasterId r:id="rId8"/>
   </p:notesMasterIdLst>
   <p:sldIdLst>
     <p:sldId id="256" r:id="rId2"/>
-    <p:sldId id="295" r:id="rId3"/>
-    <p:sldId id="296" r:id="rId4"/>
-    <p:sldId id="297" r:id="rId5"/>
-    <p:sldId id="294" r:id="rId6"/>
+    <p:sldId id="2147472478" r:id="rId3"/>
+    <p:sldId id="295" r:id="rId4"/>
+    <p:sldId id="296" r:id="rId5"/>
+    <p:sldId id="297" r:id="rId6"/>
+    <p:sldId id="294" r:id="rId7"/>
   </p:sldIdLst>
   <p:sldSz cx="12192000" cy="6858000"/>
   <p:notesSz cx="6858000" cy="9144000"/>
   <p:custDataLst>
-    <p:tags r:id="rId8"/>
+    <p:tags r:id="rId9"/>
   </p:custDataLst>
   <p:defaultTextStyle>
     <a:defPPr>
@@ -231,7 +232,7 @@
             <a:fld id="{E39D9A20-47A0-4507-821D-C8B61CB79B2C}" type="datetimeFigureOut">
               <a:rPr lang="en-GB" smtClean="0"/>
               <a:pPr/>
-              <a:t>22/04/2026</a:t>
+              <a:t>30/04/2026</a:t>
             </a:fld>
             <a:endParaRPr lang="en-GB" dirty="0"/>
           </a:p>
@@ -746,7 +747,7 @@
         <p:fade/>
       </p:transition>
     </mc:Choice>
-    <mc:Fallback xmlns="" xmlns:a16="http://schemas.microsoft.com/office/drawing/2014/main" xmlns:a14="http://schemas.microsoft.com/office/drawing/2010/main" xmlns:p15="http://schemas.microsoft.com/office/powerpoint/2012/main">
+    <mc:Fallback xmlns:p15="http://schemas.microsoft.com/office/powerpoint/2012/main" xmlns:a14="http://schemas.microsoft.com/office/drawing/2010/main" xmlns:a16="http://schemas.microsoft.com/office/drawing/2014/main" xmlns="">
       <p:transition spd="med">
         <p:fade/>
       </p:transition>
@@ -2780,6 +2781,1554 @@
 </p:sldLayout>
 </file>
 
+<file path=ppt/slideLayouts/slideLayout6.xml><?xml version="1.0" encoding="utf-8"?>
+<p:sldLayout xmlns:a="http://schemas.openxmlformats.org/drawingml/2006/main" xmlns:r="http://schemas.openxmlformats.org/officeDocument/2006/relationships" xmlns:p="http://schemas.openxmlformats.org/presentationml/2006/main" showMasterSp="0" userDrawn="1">
+  <p:cSld name="2_Cover 05">
+    <p:bg>
+      <p:bgPr>
+        <a:solidFill>
+          <a:schemeClr val="accent1"/>
+        </a:solidFill>
+        <a:effectLst/>
+      </p:bgPr>
+    </p:bg>
+    <p:spTree>
+      <p:nvGrpSpPr>
+        <p:cNvPr id="1" name=""/>
+        <p:cNvGrpSpPr/>
+        <p:nvPr/>
+      </p:nvGrpSpPr>
+      <p:grpSpPr>
+        <a:xfrm>
+          <a:off x="0" y="0"/>
+          <a:ext cx="0" cy="0"/>
+          <a:chOff x="0" y="0"/>
+          <a:chExt cx="0" cy="0"/>
+        </a:xfrm>
+      </p:grpSpPr>
+      <p:pic>
+        <p:nvPicPr>
+          <p:cNvPr id="4" name="Picture 3" descr="A picture containing light, night sky&#10;&#10;Description automatically generated">
+            <a:extLst>
+              <a:ext uri="{FF2B5EF4-FFF2-40B4-BE49-F238E27FC236}">
+                <a16:creationId xmlns:a16="http://schemas.microsoft.com/office/drawing/2014/main" id="{16F97F43-F5F4-BBB5-AFD5-322FA0967AE5}"/>
+              </a:ext>
+            </a:extLst>
+          </p:cNvPr>
+          <p:cNvPicPr>
+            <a:picLocks noChangeAspect="1"/>
+          </p:cNvPicPr>
+          <p:nvPr userDrawn="1"/>
+        </p:nvPicPr>
+        <p:blipFill>
+          <a:blip r:embed="rId3">
+            <a:extLst>
+              <a:ext uri="{28A0092B-C50C-407E-A947-70E740481C1C}">
+                <a14:useLocalDpi xmlns:a14="http://schemas.microsoft.com/office/drawing/2010/main"/>
+              </a:ext>
+            </a:extLst>
+          </a:blip>
+          <a:stretch>
+            <a:fillRect/>
+          </a:stretch>
+        </p:blipFill>
+        <p:spPr>
+          <a:xfrm>
+            <a:off x="0" y="0"/>
+            <a:ext cx="12192000" cy="6858000"/>
+          </a:xfrm>
+          <a:prstGeom prst="rect">
+            <a:avLst/>
+          </a:prstGeom>
+        </p:spPr>
+      </p:pic>
+      <p:sp>
+        <p:nvSpPr>
+          <p:cNvPr id="12" name="Rectangle 11">
+            <a:extLst>
+              <a:ext uri="{FF2B5EF4-FFF2-40B4-BE49-F238E27FC236}">
+                <a16:creationId xmlns:a16="http://schemas.microsoft.com/office/drawing/2014/main" id="{12BCE566-9F8D-8D92-B66E-82E51106748D}"/>
+              </a:ext>
+            </a:extLst>
+          </p:cNvPr>
+          <p:cNvSpPr/>
+          <p:nvPr userDrawn="1"/>
+        </p:nvSpPr>
+        <p:spPr>
+          <a:xfrm>
+            <a:off x="995363" y="0"/>
+            <a:ext cx="4427537" cy="5876925"/>
+          </a:xfrm>
+          <a:prstGeom prst="rect">
+            <a:avLst/>
+          </a:prstGeom>
+          <a:solidFill>
+            <a:schemeClr val="accent1">
+              <a:alpha val="81000"/>
+            </a:schemeClr>
+          </a:solidFill>
+          <a:ln>
+            <a:noFill/>
+          </a:ln>
+        </p:spPr>
+        <p:style>
+          <a:lnRef idx="2">
+            <a:schemeClr val="accent1">
+              <a:shade val="50000"/>
+            </a:schemeClr>
+          </a:lnRef>
+          <a:fillRef idx="1">
+            <a:schemeClr val="accent1"/>
+          </a:fillRef>
+          <a:effectRef idx="0">
+            <a:schemeClr val="accent1"/>
+          </a:effectRef>
+          <a:fontRef idx="minor">
+            <a:schemeClr val="lt1"/>
+          </a:fontRef>
+        </p:style>
+        <p:txBody>
+          <a:bodyPr lIns="54610" tIns="54610" rIns="54610" bIns="54610" rtlCol="0" anchor="ctr"/>
+          <a:lstStyle/>
+          <a:p>
+            <a:pPr algn="l"/>
+            <a:endParaRPr lang="en-US" sz="1500" err="1">
+              <a:solidFill>
+                <a:schemeClr val="bg1"/>
+              </a:solidFill>
+            </a:endParaRPr>
+          </a:p>
+        </p:txBody>
+      </p:sp>
+      <p:sp>
+        <p:nvSpPr>
+          <p:cNvPr id="17" name="Text Placeholder 16">
+            <a:extLst>
+              <a:ext uri="{FF2B5EF4-FFF2-40B4-BE49-F238E27FC236}">
+                <a16:creationId xmlns:a16="http://schemas.microsoft.com/office/drawing/2014/main" id="{CFA69F8E-C80A-AD61-B8C5-3430088FD7B4}"/>
+              </a:ext>
+            </a:extLst>
+          </p:cNvPr>
+          <p:cNvSpPr>
+            <a:spLocks noGrp="1"/>
+          </p:cNvSpPr>
+          <p:nvPr>
+            <p:ph type="body" sz="quarter" idx="10" hasCustomPrompt="1"/>
+          </p:nvPr>
+        </p:nvSpPr>
+        <p:spPr>
+          <a:xfrm>
+            <a:off x="1396999" y="1069975"/>
+            <a:ext cx="1400175" cy="1698927"/>
+          </a:xfrm>
+        </p:spPr>
+        <p:txBody>
+          <a:bodyPr>
+            <a:noAutofit/>
+          </a:bodyPr>
+          <a:lstStyle>
+            <a:lvl1pPr>
+              <a:lnSpc>
+                <a:spcPct val="80000"/>
+              </a:lnSpc>
+              <a:defRPr sz="13800">
+                <a:solidFill>
+                  <a:schemeClr val="bg1"/>
+                </a:solidFill>
+                <a:latin typeface="+mj-lt"/>
+              </a:defRPr>
+            </a:lvl1pPr>
+          </a:lstStyle>
+          <a:p>
+            <a:pPr lvl="0"/>
+            <a:r>
+              <a:rPr lang="en-US" dirty="0"/>
+              <a:t>01</a:t>
+            </a:r>
+          </a:p>
+        </p:txBody>
+      </p:sp>
+      <p:sp>
+        <p:nvSpPr>
+          <p:cNvPr id="2" name="Shape 8">
+            <a:extLst>
+              <a:ext uri="{FF2B5EF4-FFF2-40B4-BE49-F238E27FC236}">
+                <a16:creationId xmlns:a16="http://schemas.microsoft.com/office/drawing/2014/main" id="{472D1863-2A9D-4FCE-9957-082D5529A078}"/>
+              </a:ext>
+            </a:extLst>
+          </p:cNvPr>
+          <p:cNvSpPr txBox="1">
+            <a:spLocks/>
+          </p:cNvSpPr>
+          <p:nvPr userDrawn="1"/>
+        </p:nvSpPr>
+        <p:spPr>
+          <a:xfrm>
+            <a:off x="10946607" y="6266997"/>
+            <a:ext cx="242486" cy="149412"/>
+          </a:xfrm>
+          <a:prstGeom prst="rect">
+            <a:avLst/>
+          </a:prstGeom>
+        </p:spPr>
+        <p:txBody>
+          <a:bodyPr lIns="0" tIns="0" rIns="0" bIns="0" anchor="b" anchorCtr="0"/>
+          <a:lstStyle>
+            <a:defPPr>
+              <a:defRPr lang="en-US"/>
+            </a:defPPr>
+            <a:lvl1pPr marL="0" algn="l" defTabSz="457200" rtl="0" eaLnBrk="1" latinLnBrk="0" hangingPunct="1">
+              <a:defRPr sz="1000" kern="1200">
+                <a:solidFill>
+                  <a:srgbClr val="0061A8"/>
+                </a:solidFill>
+                <a:latin typeface="Arial"/>
+                <a:ea typeface="Arial"/>
+                <a:cs typeface="Arial"/>
+                <a:sym typeface="Arial"/>
+              </a:defRPr>
+            </a:lvl1pPr>
+            <a:lvl2pPr marL="457200" algn="l" defTabSz="457200" rtl="0" eaLnBrk="1" latinLnBrk="0" hangingPunct="1">
+              <a:defRPr sz="1800" kern="1200">
+                <a:solidFill>
+                  <a:schemeClr val="tx1"/>
+                </a:solidFill>
+                <a:latin typeface="+mn-lt"/>
+                <a:ea typeface="+mn-ea"/>
+                <a:cs typeface="+mn-cs"/>
+              </a:defRPr>
+            </a:lvl2pPr>
+            <a:lvl3pPr marL="914400" algn="l" defTabSz="457200" rtl="0" eaLnBrk="1" latinLnBrk="0" hangingPunct="1">
+              <a:defRPr sz="1800" kern="1200">
+                <a:solidFill>
+                  <a:schemeClr val="tx1"/>
+                </a:solidFill>
+                <a:latin typeface="+mn-lt"/>
+                <a:ea typeface="+mn-ea"/>
+                <a:cs typeface="+mn-cs"/>
+              </a:defRPr>
+            </a:lvl3pPr>
+            <a:lvl4pPr marL="1371600" algn="l" defTabSz="457200" rtl="0" eaLnBrk="1" latinLnBrk="0" hangingPunct="1">
+              <a:defRPr sz="1800" kern="1200">
+                <a:solidFill>
+                  <a:schemeClr val="tx1"/>
+                </a:solidFill>
+                <a:latin typeface="+mn-lt"/>
+                <a:ea typeface="+mn-ea"/>
+                <a:cs typeface="+mn-cs"/>
+              </a:defRPr>
+            </a:lvl4pPr>
+            <a:lvl5pPr marL="1828800" algn="l" defTabSz="457200" rtl="0" eaLnBrk="1" latinLnBrk="0" hangingPunct="1">
+              <a:defRPr sz="1800" kern="1200">
+                <a:solidFill>
+                  <a:schemeClr val="tx1"/>
+                </a:solidFill>
+                <a:latin typeface="+mn-lt"/>
+                <a:ea typeface="+mn-ea"/>
+                <a:cs typeface="+mn-cs"/>
+              </a:defRPr>
+            </a:lvl5pPr>
+            <a:lvl6pPr marL="2286000" algn="l" defTabSz="457200" rtl="0" eaLnBrk="1" latinLnBrk="0" hangingPunct="1">
+              <a:defRPr sz="1800" kern="1200">
+                <a:solidFill>
+                  <a:schemeClr val="tx1"/>
+                </a:solidFill>
+                <a:latin typeface="+mn-lt"/>
+                <a:ea typeface="+mn-ea"/>
+                <a:cs typeface="+mn-cs"/>
+              </a:defRPr>
+            </a:lvl6pPr>
+            <a:lvl7pPr marL="2743200" algn="l" defTabSz="457200" rtl="0" eaLnBrk="1" latinLnBrk="0" hangingPunct="1">
+              <a:defRPr sz="1800" kern="1200">
+                <a:solidFill>
+                  <a:schemeClr val="tx1"/>
+                </a:solidFill>
+                <a:latin typeface="+mn-lt"/>
+                <a:ea typeface="+mn-ea"/>
+                <a:cs typeface="+mn-cs"/>
+              </a:defRPr>
+            </a:lvl7pPr>
+            <a:lvl8pPr marL="3200400" algn="l" defTabSz="457200" rtl="0" eaLnBrk="1" latinLnBrk="0" hangingPunct="1">
+              <a:defRPr sz="1800" kern="1200">
+                <a:solidFill>
+                  <a:schemeClr val="tx1"/>
+                </a:solidFill>
+                <a:latin typeface="+mn-lt"/>
+                <a:ea typeface="+mn-ea"/>
+                <a:cs typeface="+mn-cs"/>
+              </a:defRPr>
+            </a:lvl8pPr>
+            <a:lvl9pPr marL="3657600" algn="l" defTabSz="457200" rtl="0" eaLnBrk="1" latinLnBrk="0" hangingPunct="1">
+              <a:defRPr sz="1800" kern="1200">
+                <a:solidFill>
+                  <a:schemeClr val="tx1"/>
+                </a:solidFill>
+                <a:latin typeface="+mn-lt"/>
+                <a:ea typeface="+mn-ea"/>
+                <a:cs typeface="+mn-cs"/>
+              </a:defRPr>
+            </a:lvl9pPr>
+          </a:lstStyle>
+          <a:p>
+            <a:pPr algn="r"/>
+            <a:fld id="{86CB4B4D-7CA3-9044-876B-883B54F8677D}" type="slidenum">
+              <a:rPr lang="nl-NL" sz="1000" smtClean="0">
+                <a:solidFill>
+                  <a:schemeClr val="bg1"/>
+                </a:solidFill>
+                <a:latin typeface="+mn-lt"/>
+                <a:ea typeface="Arial"/>
+                <a:cs typeface="Arial" panose="020B0604020202020204" pitchFamily="34" charset="0"/>
+              </a:rPr>
+              <a:pPr algn="r"/>
+              <a:t>‹#›</a:t>
+            </a:fld>
+            <a:endParaRPr lang="nl-NL" sz="1000" dirty="0">
+              <a:solidFill>
+                <a:schemeClr val="bg1"/>
+              </a:solidFill>
+              <a:latin typeface="+mn-lt"/>
+              <a:ea typeface="Arial"/>
+              <a:cs typeface="Arial" panose="020B0604020202020204" pitchFamily="34" charset="0"/>
+            </a:endParaRPr>
+          </a:p>
+        </p:txBody>
+      </p:sp>
+      <p:sp>
+        <p:nvSpPr>
+          <p:cNvPr id="3" name="TextBox 2">
+            <a:extLst>
+              <a:ext uri="{FF2B5EF4-FFF2-40B4-BE49-F238E27FC236}">
+                <a16:creationId xmlns:a16="http://schemas.microsoft.com/office/drawing/2014/main" id="{8B3F4F0B-DFEC-CB9C-8902-4C2B26BDCCF7}"/>
+              </a:ext>
+              <a:ext uri="{C183D7F6-B498-43B3-948B-1728B52AA6E4}">
+                <adec:decorative xmlns:adec="http://schemas.microsoft.com/office/drawing/2017/decorative" val="1"/>
+              </a:ext>
+            </a:extLst>
+          </p:cNvPr>
+          <p:cNvSpPr txBox="1"/>
+          <p:nvPr userDrawn="1">
+            <p:custDataLst>
+              <p:tags r:id="rId1"/>
+            </p:custDataLst>
+          </p:nvPr>
+        </p:nvSpPr>
+        <p:spPr>
+          <a:xfrm>
+            <a:off x="8967794" y="6295536"/>
+            <a:ext cx="1866200" cy="92333"/>
+          </a:xfrm>
+          <a:prstGeom prst="rect">
+            <a:avLst/>
+          </a:prstGeom>
+          <a:noFill/>
+        </p:spPr>
+        <p:txBody>
+          <a:bodyPr wrap="square" lIns="0" tIns="0" rIns="0" bIns="0" rtlCol="0">
+            <a:spAutoFit/>
+          </a:bodyPr>
+          <a:lstStyle/>
+          <a:p>
+            <a:pPr marL="0" marR="0" lvl="0" indent="0" algn="r" defTabSz="914400" rtl="0" eaLnBrk="1" fontAlgn="auto" latinLnBrk="0" hangingPunct="1">
+              <a:lnSpc>
+                <a:spcPct val="100000"/>
+              </a:lnSpc>
+              <a:spcBef>
+                <a:spcPts val="0"/>
+              </a:spcBef>
+              <a:spcAft>
+                <a:spcPts val="0"/>
+              </a:spcAft>
+              <a:buClrTx/>
+              <a:buSzTx/>
+              <a:buFontTx/>
+              <a:buNone/>
+              <a:tabLst/>
+              <a:defRPr/>
+            </a:pPr>
+            <a:r>
+              <a:rPr lang="nl-NL" sz="600" b="0" kern="1200" noProof="0" dirty="0">
+                <a:solidFill>
+                  <a:schemeClr val="bg1"/>
+                </a:solidFill>
+                <a:latin typeface="+mn-lt"/>
+                <a:ea typeface="+mn-ea"/>
+                <a:cs typeface="+mn-cs"/>
+              </a:rPr>
+              <a:t>Document Classification: KPMG Confidential</a:t>
+            </a:r>
+          </a:p>
+        </p:txBody>
+      </p:sp>
+      <p:sp>
+        <p:nvSpPr>
+          <p:cNvPr id="5" name="TextBox 4">
+            <a:extLst>
+              <a:ext uri="{FF2B5EF4-FFF2-40B4-BE49-F238E27FC236}">
+                <a16:creationId xmlns:a16="http://schemas.microsoft.com/office/drawing/2014/main" id="{CC8613AE-9C46-C63D-1287-4640F1B4BD91}"/>
+              </a:ext>
+              <a:ext uri="{C183D7F6-B498-43B3-948B-1728B52AA6E4}">
+                <adec:decorative xmlns:adec="http://schemas.microsoft.com/office/drawing/2017/decorative" val="1"/>
+              </a:ext>
+            </a:extLst>
+          </p:cNvPr>
+          <p:cNvSpPr txBox="1"/>
+          <p:nvPr userDrawn="1"/>
+        </p:nvSpPr>
+        <p:spPr>
+          <a:xfrm>
+            <a:off x="1885685" y="6266997"/>
+            <a:ext cx="4623066" cy="184666"/>
+          </a:xfrm>
+          <a:prstGeom prst="rect">
+            <a:avLst/>
+          </a:prstGeom>
+          <a:noFill/>
+        </p:spPr>
+        <p:txBody>
+          <a:bodyPr wrap="square" lIns="0" tIns="0" rIns="0" bIns="0" rtlCol="0">
+            <a:spAutoFit/>
+          </a:bodyPr>
+          <a:lstStyle/>
+          <a:p>
+            <a:pPr marL="0" marR="0" lvl="0" indent="0" algn="l" defTabSz="914400" rtl="0" eaLnBrk="1" fontAlgn="auto" latinLnBrk="0" hangingPunct="1">
+              <a:lnSpc>
+                <a:spcPct val="100000"/>
+              </a:lnSpc>
+              <a:spcBef>
+                <a:spcPts val="0"/>
+              </a:spcBef>
+              <a:spcAft>
+                <a:spcPts val="0"/>
+              </a:spcAft>
+              <a:buClrTx/>
+              <a:buSzTx/>
+              <a:buFontTx/>
+              <a:buNone/>
+              <a:tabLst/>
+              <a:defRPr/>
+            </a:pPr>
+            <a:r>
+              <a:rPr lang="nl-NL" sz="600" kern="1200" noProof="0" dirty="0">
+                <a:solidFill>
+                  <a:schemeClr val="bg1"/>
+                </a:solidFill>
+                <a:latin typeface="+mn-lt"/>
+                <a:ea typeface="+mn-ea"/>
+                <a:cs typeface="+mn-cs"/>
+              </a:rPr>
+              <a:t>© 2024 KPMG Advisory N.V., a Dutch limited liability company and a member firm of the KPMG global organisation of independent member firms affiliated with KPMG International Limited, a private English company limited by guarantee. All rights reserved.</a:t>
+            </a:r>
+          </a:p>
+        </p:txBody>
+      </p:sp>
+      <p:cxnSp>
+        <p:nvCxnSpPr>
+          <p:cNvPr id="6" name="Straight Connector 5">
+            <a:extLst>
+              <a:ext uri="{FF2B5EF4-FFF2-40B4-BE49-F238E27FC236}">
+                <a16:creationId xmlns:a16="http://schemas.microsoft.com/office/drawing/2014/main" id="{7B0C43AC-8350-C0FC-910D-0341917547AC}"/>
+              </a:ext>
+            </a:extLst>
+          </p:cNvPr>
+          <p:cNvCxnSpPr/>
+          <p:nvPr userDrawn="1"/>
+        </p:nvCxnSpPr>
+        <p:spPr>
+          <a:xfrm>
+            <a:off x="10928548" y="6266997"/>
+            <a:ext cx="0" cy="149412"/>
+          </a:xfrm>
+          <a:prstGeom prst="line">
+            <a:avLst/>
+          </a:prstGeom>
+          <a:ln w="6350">
+            <a:solidFill>
+              <a:schemeClr val="accent4"/>
+            </a:solidFill>
+          </a:ln>
+        </p:spPr>
+        <p:style>
+          <a:lnRef idx="1">
+            <a:schemeClr val="accent1"/>
+          </a:lnRef>
+          <a:fillRef idx="0">
+            <a:schemeClr val="accent1"/>
+          </a:fillRef>
+          <a:effectRef idx="0">
+            <a:schemeClr val="accent1"/>
+          </a:effectRef>
+          <a:fontRef idx="minor">
+            <a:schemeClr val="tx1"/>
+          </a:fontRef>
+        </p:style>
+      </p:cxnSp>
+      <p:sp>
+        <p:nvSpPr>
+          <p:cNvPr id="7" name="Graphic 8">
+            <a:extLst>
+              <a:ext uri="{FF2B5EF4-FFF2-40B4-BE49-F238E27FC236}">
+                <a16:creationId xmlns:a16="http://schemas.microsoft.com/office/drawing/2014/main" id="{C452456B-4CED-3D10-9BAF-080B0BAF34E4}"/>
+              </a:ext>
+            </a:extLst>
+          </p:cNvPr>
+          <p:cNvSpPr/>
+          <p:nvPr userDrawn="1"/>
+        </p:nvSpPr>
+        <p:spPr>
+          <a:xfrm>
+            <a:off x="1003200" y="6266996"/>
+            <a:ext cx="484832" cy="194706"/>
+          </a:xfrm>
+          <a:custGeom>
+            <a:avLst/>
+            <a:gdLst>
+              <a:gd name="connsiteX0" fmla="*/ 480938 w 484832"/>
+              <a:gd name="connsiteY0" fmla="*/ 148130 h 194706"/>
+              <a:gd name="connsiteX1" fmla="*/ 455744 w 484832"/>
+              <a:gd name="connsiteY1" fmla="*/ 148130 h 194706"/>
+              <a:gd name="connsiteX2" fmla="*/ 459917 w 484832"/>
+              <a:gd name="connsiteY2" fmla="*/ 131488 h 194706"/>
+              <a:gd name="connsiteX3" fmla="*/ 409445 w 484832"/>
+              <a:gd name="connsiteY3" fmla="*/ 131488 h 194706"/>
+              <a:gd name="connsiteX4" fmla="*/ 405289 w 484832"/>
+              <a:gd name="connsiteY4" fmla="*/ 148130 h 194706"/>
+              <a:gd name="connsiteX5" fmla="*/ 380916 w 484832"/>
+              <a:gd name="connsiteY5" fmla="*/ 148130 h 194706"/>
+              <a:gd name="connsiteX6" fmla="*/ 380916 w 484832"/>
+              <a:gd name="connsiteY6" fmla="*/ 144709 h 194706"/>
+              <a:gd name="connsiteX7" fmla="*/ 382079 w 484832"/>
+              <a:gd name="connsiteY7" fmla="*/ 138775 h 194706"/>
+              <a:gd name="connsiteX8" fmla="*/ 418715 w 484832"/>
+              <a:gd name="connsiteY8" fmla="*/ 103062 h 194706"/>
+              <a:gd name="connsiteX9" fmla="*/ 433698 w 484832"/>
+              <a:gd name="connsiteY9" fmla="*/ 117292 h 194706"/>
+              <a:gd name="connsiteX10" fmla="*/ 463732 w 484832"/>
+              <a:gd name="connsiteY10" fmla="*/ 117292 h 194706"/>
+              <a:gd name="connsiteX11" fmla="*/ 461234 w 484832"/>
+              <a:gd name="connsiteY11" fmla="*/ 95058 h 194706"/>
+              <a:gd name="connsiteX12" fmla="*/ 425214 w 484832"/>
+              <a:gd name="connsiteY12" fmla="*/ 82641 h 194706"/>
+              <a:gd name="connsiteX13" fmla="*/ 380916 w 484832"/>
+              <a:gd name="connsiteY13" fmla="*/ 94357 h 194706"/>
+              <a:gd name="connsiteX14" fmla="*/ 380916 w 484832"/>
+              <a:gd name="connsiteY14" fmla="*/ 3708 h 194706"/>
+              <a:gd name="connsiteX15" fmla="*/ 480938 w 484832"/>
+              <a:gd name="connsiteY15" fmla="*/ 3708 h 194706"/>
+              <a:gd name="connsiteX16" fmla="*/ 421914 w 484832"/>
+              <a:gd name="connsiteY16" fmla="*/ 172537 h 194706"/>
+              <a:gd name="connsiteX17" fmla="*/ 405101 w 484832"/>
+              <a:gd name="connsiteY17" fmla="*/ 174247 h 194706"/>
+              <a:gd name="connsiteX18" fmla="*/ 380438 w 484832"/>
+              <a:gd name="connsiteY18" fmla="*/ 151910 h 194706"/>
+              <a:gd name="connsiteX19" fmla="*/ 427027 w 484832"/>
+              <a:gd name="connsiteY19" fmla="*/ 151910 h 194706"/>
+              <a:gd name="connsiteX20" fmla="*/ 364275 w 484832"/>
+              <a:gd name="connsiteY20" fmla="*/ 90064 h 194706"/>
+              <a:gd name="connsiteX21" fmla="*/ 364275 w 484832"/>
+              <a:gd name="connsiteY21" fmla="*/ 110759 h 194706"/>
+              <a:gd name="connsiteX22" fmla="*/ 350951 w 484832"/>
+              <a:gd name="connsiteY22" fmla="*/ 139390 h 194706"/>
+              <a:gd name="connsiteX23" fmla="*/ 349360 w 484832"/>
+              <a:gd name="connsiteY23" fmla="*/ 148130 h 194706"/>
+              <a:gd name="connsiteX24" fmla="*/ 334669 w 484832"/>
+              <a:gd name="connsiteY24" fmla="*/ 148130 h 194706"/>
+              <a:gd name="connsiteX25" fmla="*/ 347223 w 484832"/>
+              <a:gd name="connsiteY25" fmla="*/ 88524 h 194706"/>
+              <a:gd name="connsiteX26" fmla="*/ 304943 w 484832"/>
+              <a:gd name="connsiteY26" fmla="*/ 88524 h 194706"/>
+              <a:gd name="connsiteX27" fmla="*/ 267110 w 484832"/>
+              <a:gd name="connsiteY27" fmla="*/ 148164 h 194706"/>
+              <a:gd name="connsiteX28" fmla="*/ 264339 w 484832"/>
+              <a:gd name="connsiteY28" fmla="*/ 148164 h 194706"/>
+              <a:gd name="connsiteX29" fmla="*/ 264339 w 484832"/>
+              <a:gd name="connsiteY29" fmla="*/ 3759 h 194706"/>
+              <a:gd name="connsiteX30" fmla="*/ 364326 w 484832"/>
+              <a:gd name="connsiteY30" fmla="*/ 3759 h 194706"/>
+              <a:gd name="connsiteX31" fmla="*/ 308449 w 484832"/>
+              <a:gd name="connsiteY31" fmla="*/ 148130 h 194706"/>
+              <a:gd name="connsiteX32" fmla="*/ 293398 w 484832"/>
+              <a:gd name="connsiteY32" fmla="*/ 148130 h 194706"/>
+              <a:gd name="connsiteX33" fmla="*/ 316163 w 484832"/>
+              <a:gd name="connsiteY33" fmla="*/ 112315 h 194706"/>
+              <a:gd name="connsiteX34" fmla="*/ 247731 w 484832"/>
+              <a:gd name="connsiteY34" fmla="*/ 88388 h 194706"/>
+              <a:gd name="connsiteX35" fmla="*/ 222709 w 484832"/>
+              <a:gd name="connsiteY35" fmla="*/ 88388 h 194706"/>
+              <a:gd name="connsiteX36" fmla="*/ 205606 w 484832"/>
+              <a:gd name="connsiteY36" fmla="*/ 148130 h 194706"/>
+              <a:gd name="connsiteX37" fmla="*/ 179027 w 484832"/>
+              <a:gd name="connsiteY37" fmla="*/ 148130 h 194706"/>
+              <a:gd name="connsiteX38" fmla="*/ 203314 w 484832"/>
+              <a:gd name="connsiteY38" fmla="*/ 119413 h 194706"/>
+              <a:gd name="connsiteX39" fmla="*/ 199893 w 484832"/>
+              <a:gd name="connsiteY39" fmla="*/ 95725 h 194706"/>
+              <a:gd name="connsiteX40" fmla="*/ 167653 w 484832"/>
+              <a:gd name="connsiteY40" fmla="*/ 88353 h 194706"/>
+              <a:gd name="connsiteX41" fmla="*/ 147796 w 484832"/>
+              <a:gd name="connsiteY41" fmla="*/ 88353 h 194706"/>
+              <a:gd name="connsiteX42" fmla="*/ 147796 w 484832"/>
+              <a:gd name="connsiteY42" fmla="*/ 3759 h 194706"/>
+              <a:gd name="connsiteX43" fmla="*/ 247697 w 484832"/>
+              <a:gd name="connsiteY43" fmla="*/ 3759 h 194706"/>
+              <a:gd name="connsiteX44" fmla="*/ 231740 w 484832"/>
+              <a:gd name="connsiteY44" fmla="*/ 148130 h 194706"/>
+              <a:gd name="connsiteX45" fmla="*/ 242258 w 484832"/>
+              <a:gd name="connsiteY45" fmla="*/ 110759 h 194706"/>
+              <a:gd name="connsiteX46" fmla="*/ 242635 w 484832"/>
+              <a:gd name="connsiteY46" fmla="*/ 148130 h 194706"/>
+              <a:gd name="connsiteX47" fmla="*/ 158981 w 484832"/>
+              <a:gd name="connsiteY47" fmla="*/ 133934 h 194706"/>
+              <a:gd name="connsiteX48" fmla="*/ 158981 w 484832"/>
+              <a:gd name="connsiteY48" fmla="*/ 133934 h 194706"/>
+              <a:gd name="connsiteX49" fmla="*/ 155920 w 484832"/>
+              <a:gd name="connsiteY49" fmla="*/ 134054 h 194706"/>
+              <a:gd name="connsiteX50" fmla="*/ 152243 w 484832"/>
+              <a:gd name="connsiteY50" fmla="*/ 134054 h 194706"/>
+              <a:gd name="connsiteX51" fmla="*/ 145846 w 484832"/>
+              <a:gd name="connsiteY51" fmla="*/ 134054 h 194706"/>
+              <a:gd name="connsiteX52" fmla="*/ 148805 w 484832"/>
+              <a:gd name="connsiteY52" fmla="*/ 123125 h 194706"/>
+              <a:gd name="connsiteX53" fmla="*/ 150207 w 484832"/>
+              <a:gd name="connsiteY53" fmla="*/ 117686 h 194706"/>
+              <a:gd name="connsiteX54" fmla="*/ 153628 w 484832"/>
+              <a:gd name="connsiteY54" fmla="*/ 104961 h 194706"/>
+              <a:gd name="connsiteX55" fmla="*/ 157972 w 484832"/>
+              <a:gd name="connsiteY55" fmla="*/ 104961 h 194706"/>
+              <a:gd name="connsiteX56" fmla="*/ 162915 w 484832"/>
+              <a:gd name="connsiteY56" fmla="*/ 104961 h 194706"/>
+              <a:gd name="connsiteX57" fmla="*/ 178668 w 484832"/>
+              <a:gd name="connsiteY57" fmla="*/ 108159 h 194706"/>
+              <a:gd name="connsiteX58" fmla="*/ 178206 w 484832"/>
+              <a:gd name="connsiteY58" fmla="*/ 119105 h 194706"/>
+              <a:gd name="connsiteX59" fmla="*/ 159084 w 484832"/>
+              <a:gd name="connsiteY59" fmla="*/ 133986 h 194706"/>
+              <a:gd name="connsiteX60" fmla="*/ 131291 w 484832"/>
+              <a:gd name="connsiteY60" fmla="*/ 93741 h 194706"/>
+              <a:gd name="connsiteX61" fmla="*/ 129717 w 484832"/>
+              <a:gd name="connsiteY61" fmla="*/ 98872 h 194706"/>
+              <a:gd name="connsiteX62" fmla="*/ 115419 w 484832"/>
+              <a:gd name="connsiteY62" fmla="*/ 146471 h 194706"/>
+              <a:gd name="connsiteX63" fmla="*/ 114854 w 484832"/>
+              <a:gd name="connsiteY63" fmla="*/ 148181 h 194706"/>
+              <a:gd name="connsiteX64" fmla="*/ 67683 w 484832"/>
+              <a:gd name="connsiteY64" fmla="*/ 148181 h 194706"/>
+              <a:gd name="connsiteX65" fmla="*/ 64006 w 484832"/>
+              <a:gd name="connsiteY65" fmla="*/ 140365 h 194706"/>
+              <a:gd name="connsiteX66" fmla="*/ 114683 w 484832"/>
+              <a:gd name="connsiteY66" fmla="*/ 88524 h 194706"/>
+              <a:gd name="connsiteX67" fmla="*/ 82187 w 484832"/>
+              <a:gd name="connsiteY67" fmla="*/ 88524 h 194706"/>
+              <a:gd name="connsiteX68" fmla="*/ 42507 w 484832"/>
+              <a:gd name="connsiteY68" fmla="*/ 131283 h 194706"/>
+              <a:gd name="connsiteX69" fmla="*/ 55351 w 484832"/>
+              <a:gd name="connsiteY69" fmla="*/ 88524 h 194706"/>
+              <a:gd name="connsiteX70" fmla="*/ 31270 w 484832"/>
+              <a:gd name="connsiteY70" fmla="*/ 88524 h 194706"/>
+              <a:gd name="connsiteX71" fmla="*/ 31270 w 484832"/>
+              <a:gd name="connsiteY71" fmla="*/ 3759 h 194706"/>
+              <a:gd name="connsiteX72" fmla="*/ 131188 w 484832"/>
+              <a:gd name="connsiteY72" fmla="*/ 3759 h 194706"/>
+              <a:gd name="connsiteX73" fmla="*/ 377119 w 484832"/>
+              <a:gd name="connsiteY73" fmla="*/ -89 h 194706"/>
+              <a:gd name="connsiteX74" fmla="*/ 377119 w 484832"/>
+              <a:gd name="connsiteY74" fmla="*/ 97076 h 194706"/>
+              <a:gd name="connsiteX75" fmla="*/ 368140 w 484832"/>
+              <a:gd name="connsiteY75" fmla="*/ 105713 h 194706"/>
+              <a:gd name="connsiteX76" fmla="*/ 368140 w 484832"/>
+              <a:gd name="connsiteY76" fmla="*/ -89 h 194706"/>
+              <a:gd name="connsiteX77" fmla="*/ 260525 w 484832"/>
+              <a:gd name="connsiteY77" fmla="*/ -89 h 194706"/>
+              <a:gd name="connsiteX78" fmla="*/ 260525 w 484832"/>
+              <a:gd name="connsiteY78" fmla="*/ 88388 h 194706"/>
+              <a:gd name="connsiteX79" fmla="*/ 251614 w 484832"/>
+              <a:gd name="connsiteY79" fmla="*/ 88388 h 194706"/>
+              <a:gd name="connsiteX80" fmla="*/ 251614 w 484832"/>
+              <a:gd name="connsiteY80" fmla="*/ -89 h 194706"/>
+              <a:gd name="connsiteX81" fmla="*/ 143965 w 484832"/>
+              <a:gd name="connsiteY81" fmla="*/ -89 h 194706"/>
+              <a:gd name="connsiteX82" fmla="*/ 143965 w 484832"/>
+              <a:gd name="connsiteY82" fmla="*/ 88524 h 194706"/>
+              <a:gd name="connsiteX83" fmla="*/ 135071 w 484832"/>
+              <a:gd name="connsiteY83" fmla="*/ 88524 h 194706"/>
+              <a:gd name="connsiteX84" fmla="*/ 135071 w 484832"/>
+              <a:gd name="connsiteY84" fmla="*/ -89 h 194706"/>
+              <a:gd name="connsiteX85" fmla="*/ 27456 w 484832"/>
+              <a:gd name="connsiteY85" fmla="*/ -89 h 194706"/>
+              <a:gd name="connsiteX86" fmla="*/ 27456 w 484832"/>
+              <a:gd name="connsiteY86" fmla="*/ 100907 h 194706"/>
+              <a:gd name="connsiteX87" fmla="*/ -47 w 484832"/>
+              <a:gd name="connsiteY87" fmla="*/ 192480 h 194706"/>
+              <a:gd name="connsiteX88" fmla="*/ 24120 w 484832"/>
+              <a:gd name="connsiteY88" fmla="*/ 192480 h 194706"/>
+              <a:gd name="connsiteX89" fmla="*/ 36247 w 484832"/>
+              <a:gd name="connsiteY89" fmla="*/ 151927 h 194706"/>
+              <a:gd name="connsiteX90" fmla="*/ 39667 w 484832"/>
+              <a:gd name="connsiteY90" fmla="*/ 151927 h 194706"/>
+              <a:gd name="connsiteX91" fmla="*/ 59696 w 484832"/>
+              <a:gd name="connsiteY91" fmla="*/ 192480 h 194706"/>
+              <a:gd name="connsiteX92" fmla="*/ 89028 w 484832"/>
+              <a:gd name="connsiteY92" fmla="*/ 192480 h 194706"/>
+              <a:gd name="connsiteX93" fmla="*/ 69513 w 484832"/>
+              <a:gd name="connsiteY93" fmla="*/ 151927 h 194706"/>
+              <a:gd name="connsiteX94" fmla="*/ 113623 w 484832"/>
+              <a:gd name="connsiteY94" fmla="*/ 151927 h 194706"/>
+              <a:gd name="connsiteX95" fmla="*/ 101377 w 484832"/>
+              <a:gd name="connsiteY95" fmla="*/ 192480 h 194706"/>
+              <a:gd name="connsiteX96" fmla="*/ 127785 w 484832"/>
+              <a:gd name="connsiteY96" fmla="*/ 192480 h 194706"/>
+              <a:gd name="connsiteX97" fmla="*/ 139860 w 484832"/>
+              <a:gd name="connsiteY97" fmla="*/ 152047 h 194706"/>
+              <a:gd name="connsiteX98" fmla="*/ 145641 w 484832"/>
+              <a:gd name="connsiteY98" fmla="*/ 152047 h 194706"/>
+              <a:gd name="connsiteX99" fmla="*/ 145641 w 484832"/>
+              <a:gd name="connsiteY99" fmla="*/ 151927 h 194706"/>
+              <a:gd name="connsiteX100" fmla="*/ 204408 w 484832"/>
+              <a:gd name="connsiteY100" fmla="*/ 151927 h 194706"/>
+              <a:gd name="connsiteX101" fmla="*/ 192761 w 484832"/>
+              <a:gd name="connsiteY101" fmla="*/ 192360 h 194706"/>
+              <a:gd name="connsiteX102" fmla="*/ 219374 w 484832"/>
+              <a:gd name="connsiteY102" fmla="*/ 192360 h 194706"/>
+              <a:gd name="connsiteX103" fmla="*/ 230662 w 484832"/>
+              <a:gd name="connsiteY103" fmla="*/ 151927 h 194706"/>
+              <a:gd name="connsiteX104" fmla="*/ 242635 w 484832"/>
+              <a:gd name="connsiteY104" fmla="*/ 151927 h 194706"/>
+              <a:gd name="connsiteX105" fmla="*/ 242960 w 484832"/>
+              <a:gd name="connsiteY105" fmla="*/ 192360 h 194706"/>
+              <a:gd name="connsiteX106" fmla="*/ 265280 w 484832"/>
+              <a:gd name="connsiteY106" fmla="*/ 192360 h 194706"/>
+              <a:gd name="connsiteX107" fmla="*/ 290935 w 484832"/>
+              <a:gd name="connsiteY107" fmla="*/ 151927 h 194706"/>
+              <a:gd name="connsiteX108" fmla="*/ 307713 w 484832"/>
+              <a:gd name="connsiteY108" fmla="*/ 151927 h 194706"/>
+              <a:gd name="connsiteX109" fmla="*/ 299059 w 484832"/>
+              <a:gd name="connsiteY109" fmla="*/ 192360 h 194706"/>
+              <a:gd name="connsiteX110" fmla="*/ 325227 w 484832"/>
+              <a:gd name="connsiteY110" fmla="*/ 192360 h 194706"/>
+              <a:gd name="connsiteX111" fmla="*/ 333779 w 484832"/>
+              <a:gd name="connsiteY111" fmla="*/ 151927 h 194706"/>
+              <a:gd name="connsiteX112" fmla="*/ 348933 w 484832"/>
+              <a:gd name="connsiteY112" fmla="*/ 151927 h 194706"/>
+              <a:gd name="connsiteX113" fmla="*/ 359845 w 484832"/>
+              <a:gd name="connsiteY113" fmla="*/ 183517 h 194706"/>
+              <a:gd name="connsiteX114" fmla="*/ 397131 w 484832"/>
+              <a:gd name="connsiteY114" fmla="*/ 194617 h 194706"/>
+              <a:gd name="connsiteX115" fmla="*/ 445807 w 484832"/>
+              <a:gd name="connsiteY115" fmla="*/ 188648 h 194706"/>
+              <a:gd name="connsiteX116" fmla="*/ 454872 w 484832"/>
+              <a:gd name="connsiteY116" fmla="*/ 151927 h 194706"/>
+              <a:gd name="connsiteX117" fmla="*/ 484786 w 484832"/>
+              <a:gd name="connsiteY117" fmla="*/ 151927 h 194706"/>
+              <a:gd name="connsiteX118" fmla="*/ 484786 w 484832"/>
+              <a:gd name="connsiteY118" fmla="*/ -89 h 194706"/>
+            </a:gdLst>
+            <a:ahLst/>
+            <a:cxnLst>
+              <a:cxn ang="0">
+                <a:pos x="connsiteX0" y="connsiteY0"/>
+              </a:cxn>
+              <a:cxn ang="0">
+                <a:pos x="connsiteX1" y="connsiteY1"/>
+              </a:cxn>
+              <a:cxn ang="0">
+                <a:pos x="connsiteX2" y="connsiteY2"/>
+              </a:cxn>
+              <a:cxn ang="0">
+                <a:pos x="connsiteX3" y="connsiteY3"/>
+              </a:cxn>
+              <a:cxn ang="0">
+                <a:pos x="connsiteX4" y="connsiteY4"/>
+              </a:cxn>
+              <a:cxn ang="0">
+                <a:pos x="connsiteX5" y="connsiteY5"/>
+              </a:cxn>
+              <a:cxn ang="0">
+                <a:pos x="connsiteX6" y="connsiteY6"/>
+              </a:cxn>
+              <a:cxn ang="0">
+                <a:pos x="connsiteX7" y="connsiteY7"/>
+              </a:cxn>
+              <a:cxn ang="0">
+                <a:pos x="connsiteX8" y="connsiteY8"/>
+              </a:cxn>
+              <a:cxn ang="0">
+                <a:pos x="connsiteX9" y="connsiteY9"/>
+              </a:cxn>
+              <a:cxn ang="0">
+                <a:pos x="connsiteX10" y="connsiteY10"/>
+              </a:cxn>
+              <a:cxn ang="0">
+                <a:pos x="connsiteX11" y="connsiteY11"/>
+              </a:cxn>
+              <a:cxn ang="0">
+                <a:pos x="connsiteX12" y="connsiteY12"/>
+              </a:cxn>
+              <a:cxn ang="0">
+                <a:pos x="connsiteX13" y="connsiteY13"/>
+              </a:cxn>
+              <a:cxn ang="0">
+                <a:pos x="connsiteX14" y="connsiteY14"/>
+              </a:cxn>
+              <a:cxn ang="0">
+                <a:pos x="connsiteX15" y="connsiteY15"/>
+              </a:cxn>
+              <a:cxn ang="0">
+                <a:pos x="connsiteX16" y="connsiteY16"/>
+              </a:cxn>
+              <a:cxn ang="0">
+                <a:pos x="connsiteX17" y="connsiteY17"/>
+              </a:cxn>
+              <a:cxn ang="0">
+                <a:pos x="connsiteX18" y="connsiteY18"/>
+              </a:cxn>
+              <a:cxn ang="0">
+                <a:pos x="connsiteX19" y="connsiteY19"/>
+              </a:cxn>
+              <a:cxn ang="0">
+                <a:pos x="connsiteX20" y="connsiteY20"/>
+              </a:cxn>
+              <a:cxn ang="0">
+                <a:pos x="connsiteX21" y="connsiteY21"/>
+              </a:cxn>
+              <a:cxn ang="0">
+                <a:pos x="connsiteX22" y="connsiteY22"/>
+              </a:cxn>
+              <a:cxn ang="0">
+                <a:pos x="connsiteX23" y="connsiteY23"/>
+              </a:cxn>
+              <a:cxn ang="0">
+                <a:pos x="connsiteX24" y="connsiteY24"/>
+              </a:cxn>
+              <a:cxn ang="0">
+                <a:pos x="connsiteX25" y="connsiteY25"/>
+              </a:cxn>
+              <a:cxn ang="0">
+                <a:pos x="connsiteX26" y="connsiteY26"/>
+              </a:cxn>
+              <a:cxn ang="0">
+                <a:pos x="connsiteX27" y="connsiteY27"/>
+              </a:cxn>
+              <a:cxn ang="0">
+                <a:pos x="connsiteX28" y="connsiteY28"/>
+              </a:cxn>
+              <a:cxn ang="0">
+                <a:pos x="connsiteX29" y="connsiteY29"/>
+              </a:cxn>
+              <a:cxn ang="0">
+                <a:pos x="connsiteX30" y="connsiteY30"/>
+              </a:cxn>
+              <a:cxn ang="0">
+                <a:pos x="connsiteX31" y="connsiteY31"/>
+              </a:cxn>
+              <a:cxn ang="0">
+                <a:pos x="connsiteX32" y="connsiteY32"/>
+              </a:cxn>
+              <a:cxn ang="0">
+                <a:pos x="connsiteX33" y="connsiteY33"/>
+              </a:cxn>
+              <a:cxn ang="0">
+                <a:pos x="connsiteX34" y="connsiteY34"/>
+              </a:cxn>
+              <a:cxn ang="0">
+                <a:pos x="connsiteX35" y="connsiteY35"/>
+              </a:cxn>
+              <a:cxn ang="0">
+                <a:pos x="connsiteX36" y="connsiteY36"/>
+              </a:cxn>
+              <a:cxn ang="0">
+                <a:pos x="connsiteX37" y="connsiteY37"/>
+              </a:cxn>
+              <a:cxn ang="0">
+                <a:pos x="connsiteX38" y="connsiteY38"/>
+              </a:cxn>
+              <a:cxn ang="0">
+                <a:pos x="connsiteX39" y="connsiteY39"/>
+              </a:cxn>
+              <a:cxn ang="0">
+                <a:pos x="connsiteX40" y="connsiteY40"/>
+              </a:cxn>
+              <a:cxn ang="0">
+                <a:pos x="connsiteX41" y="connsiteY41"/>
+              </a:cxn>
+              <a:cxn ang="0">
+                <a:pos x="connsiteX42" y="connsiteY42"/>
+              </a:cxn>
+              <a:cxn ang="0">
+                <a:pos x="connsiteX43" y="connsiteY43"/>
+              </a:cxn>
+              <a:cxn ang="0">
+                <a:pos x="connsiteX44" y="connsiteY44"/>
+              </a:cxn>
+              <a:cxn ang="0">
+                <a:pos x="connsiteX45" y="connsiteY45"/>
+              </a:cxn>
+              <a:cxn ang="0">
+                <a:pos x="connsiteX46" y="connsiteY46"/>
+              </a:cxn>
+              <a:cxn ang="0">
+                <a:pos x="connsiteX47" y="connsiteY47"/>
+              </a:cxn>
+              <a:cxn ang="0">
+                <a:pos x="connsiteX48" y="connsiteY48"/>
+              </a:cxn>
+              <a:cxn ang="0">
+                <a:pos x="connsiteX49" y="connsiteY49"/>
+              </a:cxn>
+              <a:cxn ang="0">
+                <a:pos x="connsiteX50" y="connsiteY50"/>
+              </a:cxn>
+              <a:cxn ang="0">
+                <a:pos x="connsiteX51" y="connsiteY51"/>
+              </a:cxn>
+              <a:cxn ang="0">
+                <a:pos x="connsiteX52" y="connsiteY52"/>
+              </a:cxn>
+              <a:cxn ang="0">
+                <a:pos x="connsiteX53" y="connsiteY53"/>
+              </a:cxn>
+              <a:cxn ang="0">
+                <a:pos x="connsiteX54" y="connsiteY54"/>
+              </a:cxn>
+              <a:cxn ang="0">
+                <a:pos x="connsiteX55" y="connsiteY55"/>
+              </a:cxn>
+              <a:cxn ang="0">
+                <a:pos x="connsiteX56" y="connsiteY56"/>
+              </a:cxn>
+              <a:cxn ang="0">
+                <a:pos x="connsiteX57" y="connsiteY57"/>
+              </a:cxn>
+              <a:cxn ang="0">
+                <a:pos x="connsiteX58" y="connsiteY58"/>
+              </a:cxn>
+              <a:cxn ang="0">
+                <a:pos x="connsiteX59" y="connsiteY59"/>
+              </a:cxn>
+              <a:cxn ang="0">
+                <a:pos x="connsiteX60" y="connsiteY60"/>
+              </a:cxn>
+              <a:cxn ang="0">
+                <a:pos x="connsiteX61" y="connsiteY61"/>
+              </a:cxn>
+              <a:cxn ang="0">
+                <a:pos x="connsiteX62" y="connsiteY62"/>
+              </a:cxn>
+              <a:cxn ang="0">
+                <a:pos x="connsiteX63" y="connsiteY63"/>
+              </a:cxn>
+              <a:cxn ang="0">
+                <a:pos x="connsiteX64" y="connsiteY64"/>
+              </a:cxn>
+              <a:cxn ang="0">
+                <a:pos x="connsiteX65" y="connsiteY65"/>
+              </a:cxn>
+              <a:cxn ang="0">
+                <a:pos x="connsiteX66" y="connsiteY66"/>
+              </a:cxn>
+              <a:cxn ang="0">
+                <a:pos x="connsiteX67" y="connsiteY67"/>
+              </a:cxn>
+              <a:cxn ang="0">
+                <a:pos x="connsiteX68" y="connsiteY68"/>
+              </a:cxn>
+              <a:cxn ang="0">
+                <a:pos x="connsiteX69" y="connsiteY69"/>
+              </a:cxn>
+              <a:cxn ang="0">
+                <a:pos x="connsiteX70" y="connsiteY70"/>
+              </a:cxn>
+              <a:cxn ang="0">
+                <a:pos x="connsiteX71" y="connsiteY71"/>
+              </a:cxn>
+              <a:cxn ang="0">
+                <a:pos x="connsiteX72" y="connsiteY72"/>
+              </a:cxn>
+              <a:cxn ang="0">
+                <a:pos x="connsiteX73" y="connsiteY73"/>
+              </a:cxn>
+              <a:cxn ang="0">
+                <a:pos x="connsiteX74" y="connsiteY74"/>
+              </a:cxn>
+              <a:cxn ang="0">
+                <a:pos x="connsiteX75" y="connsiteY75"/>
+              </a:cxn>
+              <a:cxn ang="0">
+                <a:pos x="connsiteX76" y="connsiteY76"/>
+              </a:cxn>
+              <a:cxn ang="0">
+                <a:pos x="connsiteX77" y="connsiteY77"/>
+              </a:cxn>
+              <a:cxn ang="0">
+                <a:pos x="connsiteX78" y="connsiteY78"/>
+              </a:cxn>
+              <a:cxn ang="0">
+                <a:pos x="connsiteX79" y="connsiteY79"/>
+              </a:cxn>
+              <a:cxn ang="0">
+                <a:pos x="connsiteX80" y="connsiteY80"/>
+              </a:cxn>
+              <a:cxn ang="0">
+                <a:pos x="connsiteX81" y="connsiteY81"/>
+              </a:cxn>
+              <a:cxn ang="0">
+                <a:pos x="connsiteX82" y="connsiteY82"/>
+              </a:cxn>
+              <a:cxn ang="0">
+                <a:pos x="connsiteX83" y="connsiteY83"/>
+              </a:cxn>
+              <a:cxn ang="0">
+                <a:pos x="connsiteX84" y="connsiteY84"/>
+              </a:cxn>
+              <a:cxn ang="0">
+                <a:pos x="connsiteX85" y="connsiteY85"/>
+              </a:cxn>
+              <a:cxn ang="0">
+                <a:pos x="connsiteX86" y="connsiteY86"/>
+              </a:cxn>
+              <a:cxn ang="0">
+                <a:pos x="connsiteX87" y="connsiteY87"/>
+              </a:cxn>
+              <a:cxn ang="0">
+                <a:pos x="connsiteX88" y="connsiteY88"/>
+              </a:cxn>
+              <a:cxn ang="0">
+                <a:pos x="connsiteX89" y="connsiteY89"/>
+              </a:cxn>
+              <a:cxn ang="0">
+                <a:pos x="connsiteX90" y="connsiteY90"/>
+              </a:cxn>
+              <a:cxn ang="0">
+                <a:pos x="connsiteX91" y="connsiteY91"/>
+              </a:cxn>
+              <a:cxn ang="0">
+                <a:pos x="connsiteX92" y="connsiteY92"/>
+              </a:cxn>
+              <a:cxn ang="0">
+                <a:pos x="connsiteX93" y="connsiteY93"/>
+              </a:cxn>
+              <a:cxn ang="0">
+                <a:pos x="connsiteX94" y="connsiteY94"/>
+              </a:cxn>
+              <a:cxn ang="0">
+                <a:pos x="connsiteX95" y="connsiteY95"/>
+              </a:cxn>
+              <a:cxn ang="0">
+                <a:pos x="connsiteX96" y="connsiteY96"/>
+              </a:cxn>
+              <a:cxn ang="0">
+                <a:pos x="connsiteX97" y="connsiteY97"/>
+              </a:cxn>
+              <a:cxn ang="0">
+                <a:pos x="connsiteX98" y="connsiteY98"/>
+              </a:cxn>
+              <a:cxn ang="0">
+                <a:pos x="connsiteX99" y="connsiteY99"/>
+              </a:cxn>
+              <a:cxn ang="0">
+                <a:pos x="connsiteX100" y="connsiteY100"/>
+              </a:cxn>
+              <a:cxn ang="0">
+                <a:pos x="connsiteX101" y="connsiteY101"/>
+              </a:cxn>
+              <a:cxn ang="0">
+                <a:pos x="connsiteX102" y="connsiteY102"/>
+              </a:cxn>
+              <a:cxn ang="0">
+                <a:pos x="connsiteX103" y="connsiteY103"/>
+              </a:cxn>
+              <a:cxn ang="0">
+                <a:pos x="connsiteX104" y="connsiteY104"/>
+              </a:cxn>
+              <a:cxn ang="0">
+                <a:pos x="connsiteX105" y="connsiteY105"/>
+              </a:cxn>
+              <a:cxn ang="0">
+                <a:pos x="connsiteX106" y="connsiteY106"/>
+              </a:cxn>
+              <a:cxn ang="0">
+                <a:pos x="connsiteX107" y="connsiteY107"/>
+              </a:cxn>
+              <a:cxn ang="0">
+                <a:pos x="connsiteX108" y="connsiteY108"/>
+              </a:cxn>
+              <a:cxn ang="0">
+                <a:pos x="connsiteX109" y="connsiteY109"/>
+              </a:cxn>
+              <a:cxn ang="0">
+                <a:pos x="connsiteX110" y="connsiteY110"/>
+              </a:cxn>
+              <a:cxn ang="0">
+                <a:pos x="connsiteX111" y="connsiteY111"/>
+              </a:cxn>
+              <a:cxn ang="0">
+                <a:pos x="connsiteX112" y="connsiteY112"/>
+              </a:cxn>
+              <a:cxn ang="0">
+                <a:pos x="connsiteX113" y="connsiteY113"/>
+              </a:cxn>
+              <a:cxn ang="0">
+                <a:pos x="connsiteX114" y="connsiteY114"/>
+              </a:cxn>
+              <a:cxn ang="0">
+                <a:pos x="connsiteX115" y="connsiteY115"/>
+              </a:cxn>
+              <a:cxn ang="0">
+                <a:pos x="connsiteX116" y="connsiteY116"/>
+              </a:cxn>
+              <a:cxn ang="0">
+                <a:pos x="connsiteX117" y="connsiteY117"/>
+              </a:cxn>
+              <a:cxn ang="0">
+                <a:pos x="connsiteX118" y="connsiteY118"/>
+              </a:cxn>
+            </a:cxnLst>
+            <a:rect l="l" t="t" r="r" b="b"/>
+            <a:pathLst>
+              <a:path w="484832" h="194706">
+                <a:moveTo>
+                  <a:pt x="480938" y="148130"/>
+                </a:moveTo>
+                <a:lnTo>
+                  <a:pt x="455744" y="148130"/>
+                </a:lnTo>
+                <a:lnTo>
+                  <a:pt x="459917" y="131488"/>
+                </a:lnTo>
+                <a:lnTo>
+                  <a:pt x="409445" y="131488"/>
+                </a:lnTo>
+                <a:lnTo>
+                  <a:pt x="405289" y="148130"/>
+                </a:lnTo>
+                <a:lnTo>
+                  <a:pt x="380916" y="148130"/>
+                </a:lnTo>
+                <a:lnTo>
+                  <a:pt x="380916" y="144709"/>
+                </a:lnTo>
+                <a:cubicBezTo>
+                  <a:pt x="381293" y="142845"/>
+                  <a:pt x="381618" y="140878"/>
+                  <a:pt x="382079" y="138775"/>
+                </a:cubicBezTo>
+                <a:cubicBezTo>
+                  <a:pt x="386526" y="120816"/>
+                  <a:pt x="398311" y="103062"/>
+                  <a:pt x="418715" y="103062"/>
+                </a:cubicBezTo>
+                <a:cubicBezTo>
+                  <a:pt x="426771" y="103062"/>
+                  <a:pt x="434792" y="106141"/>
+                  <a:pt x="433698" y="117292"/>
+                </a:cubicBezTo>
+                <a:lnTo>
+                  <a:pt x="463732" y="117292"/>
+                </a:lnTo>
+                <a:cubicBezTo>
+                  <a:pt x="464912" y="112161"/>
+                  <a:pt x="466896" y="103216"/>
+                  <a:pt x="461234" y="95058"/>
+                </a:cubicBezTo>
+                <a:cubicBezTo>
+                  <a:pt x="454821" y="86198"/>
+                  <a:pt x="441942" y="82641"/>
+                  <a:pt x="425214" y="82641"/>
+                </a:cubicBezTo>
+                <a:cubicBezTo>
+                  <a:pt x="413328" y="82641"/>
+                  <a:pt x="395933" y="84539"/>
+                  <a:pt x="380916" y="94357"/>
+                </a:cubicBezTo>
+                <a:lnTo>
+                  <a:pt x="380916" y="3708"/>
+                </a:lnTo>
+                <a:lnTo>
+                  <a:pt x="480938" y="3708"/>
+                </a:lnTo>
+                <a:close/>
+                <a:moveTo>
+                  <a:pt x="421914" y="172537"/>
+                </a:moveTo>
+                <a:cubicBezTo>
+                  <a:pt x="416372" y="173606"/>
+                  <a:pt x="410745" y="174179"/>
+                  <a:pt x="405101" y="174247"/>
+                </a:cubicBezTo>
+                <a:cubicBezTo>
+                  <a:pt x="390683" y="174247"/>
+                  <a:pt x="380643" y="167543"/>
+                  <a:pt x="380438" y="151910"/>
+                </a:cubicBezTo>
+                <a:lnTo>
+                  <a:pt x="427027" y="151910"/>
+                </a:lnTo>
+                <a:close/>
+                <a:moveTo>
+                  <a:pt x="364275" y="90064"/>
+                </a:moveTo>
+                <a:lnTo>
+                  <a:pt x="364275" y="110759"/>
+                </a:lnTo>
+                <a:cubicBezTo>
+                  <a:pt x="358044" y="119364"/>
+                  <a:pt x="353522" y="129082"/>
+                  <a:pt x="350951" y="139390"/>
+                </a:cubicBezTo>
+                <a:cubicBezTo>
+                  <a:pt x="350195" y="142258"/>
+                  <a:pt x="349663" y="145180"/>
+                  <a:pt x="349360" y="148130"/>
+                </a:cubicBezTo>
+                <a:lnTo>
+                  <a:pt x="334669" y="148130"/>
+                </a:lnTo>
+                <a:lnTo>
+                  <a:pt x="347223" y="88524"/>
+                </a:lnTo>
+                <a:lnTo>
+                  <a:pt x="304943" y="88524"/>
+                </a:lnTo>
+                <a:lnTo>
+                  <a:pt x="267110" y="148164"/>
+                </a:lnTo>
+                <a:lnTo>
+                  <a:pt x="264339" y="148164"/>
+                </a:lnTo>
+                <a:lnTo>
+                  <a:pt x="264339" y="3759"/>
+                </a:lnTo>
+                <a:lnTo>
+                  <a:pt x="364326" y="3759"/>
+                </a:lnTo>
+                <a:close/>
+                <a:moveTo>
+                  <a:pt x="308449" y="148130"/>
+                </a:moveTo>
+                <a:lnTo>
+                  <a:pt x="293398" y="148130"/>
+                </a:lnTo>
+                <a:lnTo>
+                  <a:pt x="316163" y="112315"/>
+                </a:lnTo>
+                <a:close/>
+                <a:moveTo>
+                  <a:pt x="247731" y="88388"/>
+                </a:moveTo>
+                <a:lnTo>
+                  <a:pt x="222709" y="88388"/>
+                </a:lnTo>
+                <a:lnTo>
+                  <a:pt x="205606" y="148130"/>
+                </a:lnTo>
+                <a:lnTo>
+                  <a:pt x="179027" y="148130"/>
+                </a:lnTo>
+                <a:cubicBezTo>
+                  <a:pt x="192538" y="143136"/>
+                  <a:pt x="200765" y="133592"/>
+                  <a:pt x="203314" y="119413"/>
+                </a:cubicBezTo>
+                <a:cubicBezTo>
+                  <a:pt x="205400" y="108399"/>
+                  <a:pt x="204408" y="101164"/>
+                  <a:pt x="199893" y="95725"/>
+                </a:cubicBezTo>
+                <a:cubicBezTo>
+                  <a:pt x="193154" y="87652"/>
+                  <a:pt x="179642" y="88353"/>
+                  <a:pt x="167653" y="88353"/>
+                </a:cubicBezTo>
+                <a:lnTo>
+                  <a:pt x="147796" y="88353"/>
+                </a:lnTo>
+                <a:lnTo>
+                  <a:pt x="147796" y="3759"/>
+                </a:lnTo>
+                <a:lnTo>
+                  <a:pt x="247697" y="3759"/>
+                </a:lnTo>
+                <a:close/>
+                <a:moveTo>
+                  <a:pt x="231740" y="148130"/>
+                </a:moveTo>
+                <a:lnTo>
+                  <a:pt x="242258" y="110759"/>
+                </a:lnTo>
+                <a:lnTo>
+                  <a:pt x="242635" y="148130"/>
+                </a:lnTo>
+                <a:close/>
+                <a:moveTo>
+                  <a:pt x="158981" y="133934"/>
+                </a:moveTo>
+                <a:lnTo>
+                  <a:pt x="158981" y="133934"/>
+                </a:lnTo>
+                <a:cubicBezTo>
+                  <a:pt x="158007" y="133934"/>
+                  <a:pt x="157032" y="134054"/>
+                  <a:pt x="155920" y="134054"/>
+                </a:cubicBezTo>
+                <a:cubicBezTo>
+                  <a:pt x="154466" y="134054"/>
+                  <a:pt x="153320" y="134054"/>
+                  <a:pt x="152243" y="134054"/>
+                </a:cubicBezTo>
+                <a:lnTo>
+                  <a:pt x="145846" y="134054"/>
+                </a:lnTo>
+                <a:lnTo>
+                  <a:pt x="148805" y="123125"/>
+                </a:lnTo>
+                <a:lnTo>
+                  <a:pt x="150207" y="117686"/>
+                </a:lnTo>
+                <a:lnTo>
+                  <a:pt x="153628" y="104961"/>
+                </a:lnTo>
+                <a:cubicBezTo>
+                  <a:pt x="155116" y="104961"/>
+                  <a:pt x="156570" y="104961"/>
+                  <a:pt x="157972" y="104961"/>
+                </a:cubicBezTo>
+                <a:lnTo>
+                  <a:pt x="162915" y="104961"/>
+                </a:lnTo>
+                <a:cubicBezTo>
+                  <a:pt x="171467" y="104961"/>
+                  <a:pt x="176718" y="105440"/>
+                  <a:pt x="178668" y="108159"/>
+                </a:cubicBezTo>
+                <a:cubicBezTo>
+                  <a:pt x="180156" y="110212"/>
+                  <a:pt x="179967" y="113735"/>
+                  <a:pt x="178206" y="119105"/>
+                </a:cubicBezTo>
+                <a:cubicBezTo>
+                  <a:pt x="175196" y="128341"/>
+                  <a:pt x="171364" y="133045"/>
+                  <a:pt x="159084" y="133986"/>
+                </a:cubicBezTo>
+                <a:moveTo>
+                  <a:pt x="131291" y="93741"/>
+                </a:moveTo>
+                <a:lnTo>
+                  <a:pt x="129717" y="98872"/>
+                </a:lnTo>
+                <a:lnTo>
+                  <a:pt x="115419" y="146471"/>
+                </a:lnTo>
+                <a:lnTo>
+                  <a:pt x="114854" y="148181"/>
+                </a:lnTo>
+                <a:lnTo>
+                  <a:pt x="67683" y="148181"/>
+                </a:lnTo>
+                <a:lnTo>
+                  <a:pt x="64006" y="140365"/>
+                </a:lnTo>
+                <a:lnTo>
+                  <a:pt x="114683" y="88524"/>
+                </a:lnTo>
+                <a:lnTo>
+                  <a:pt x="82187" y="88524"/>
+                </a:lnTo>
+                <a:lnTo>
+                  <a:pt x="42507" y="131283"/>
+                </a:lnTo>
+                <a:lnTo>
+                  <a:pt x="55351" y="88524"/>
+                </a:lnTo>
+                <a:lnTo>
+                  <a:pt x="31270" y="88524"/>
+                </a:lnTo>
+                <a:lnTo>
+                  <a:pt x="31270" y="3759"/>
+                </a:lnTo>
+                <a:lnTo>
+                  <a:pt x="131188" y="3759"/>
+                </a:lnTo>
+                <a:close/>
+                <a:moveTo>
+                  <a:pt x="377119" y="-89"/>
+                </a:moveTo>
+                <a:lnTo>
+                  <a:pt x="377119" y="97076"/>
+                </a:lnTo>
+                <a:cubicBezTo>
+                  <a:pt x="373861" y="99667"/>
+                  <a:pt x="370856" y="102560"/>
+                  <a:pt x="368140" y="105713"/>
+                </a:cubicBezTo>
+                <a:lnTo>
+                  <a:pt x="368140" y="-89"/>
+                </a:lnTo>
+                <a:lnTo>
+                  <a:pt x="260525" y="-89"/>
+                </a:lnTo>
+                <a:lnTo>
+                  <a:pt x="260525" y="88388"/>
+                </a:lnTo>
+                <a:lnTo>
+                  <a:pt x="251614" y="88388"/>
+                </a:lnTo>
+                <a:lnTo>
+                  <a:pt x="251614" y="-89"/>
+                </a:lnTo>
+                <a:lnTo>
+                  <a:pt x="143965" y="-89"/>
+                </a:lnTo>
+                <a:lnTo>
+                  <a:pt x="143965" y="88524"/>
+                </a:lnTo>
+                <a:lnTo>
+                  <a:pt x="135071" y="88524"/>
+                </a:lnTo>
+                <a:lnTo>
+                  <a:pt x="135071" y="-89"/>
+                </a:lnTo>
+                <a:lnTo>
+                  <a:pt x="27456" y="-89"/>
+                </a:lnTo>
+                <a:lnTo>
+                  <a:pt x="27456" y="100907"/>
+                </a:lnTo>
+                <a:lnTo>
+                  <a:pt x="-47" y="192480"/>
+                </a:lnTo>
+                <a:lnTo>
+                  <a:pt x="24120" y="192480"/>
+                </a:lnTo>
+                <a:lnTo>
+                  <a:pt x="36247" y="151927"/>
+                </a:lnTo>
+                <a:lnTo>
+                  <a:pt x="39667" y="151927"/>
+                </a:lnTo>
+                <a:lnTo>
+                  <a:pt x="59696" y="192480"/>
+                </a:lnTo>
+                <a:lnTo>
+                  <a:pt x="89028" y="192480"/>
+                </a:lnTo>
+                <a:lnTo>
+                  <a:pt x="69513" y="151927"/>
+                </a:lnTo>
+                <a:lnTo>
+                  <a:pt x="113623" y="151927"/>
+                </a:lnTo>
+                <a:lnTo>
+                  <a:pt x="101377" y="192480"/>
+                </a:lnTo>
+                <a:lnTo>
+                  <a:pt x="127785" y="192480"/>
+                </a:lnTo>
+                <a:lnTo>
+                  <a:pt x="139860" y="152047"/>
+                </a:lnTo>
+                <a:lnTo>
+                  <a:pt x="145641" y="152047"/>
+                </a:lnTo>
+                <a:lnTo>
+                  <a:pt x="145641" y="151927"/>
+                </a:lnTo>
+                <a:lnTo>
+                  <a:pt x="204408" y="151927"/>
+                </a:lnTo>
+                <a:lnTo>
+                  <a:pt x="192761" y="192360"/>
+                </a:lnTo>
+                <a:lnTo>
+                  <a:pt x="219374" y="192360"/>
+                </a:lnTo>
+                <a:lnTo>
+                  <a:pt x="230662" y="151927"/>
+                </a:lnTo>
+                <a:lnTo>
+                  <a:pt x="242635" y="151927"/>
+                </a:lnTo>
+                <a:lnTo>
+                  <a:pt x="242960" y="192360"/>
+                </a:lnTo>
+                <a:lnTo>
+                  <a:pt x="265280" y="192360"/>
+                </a:lnTo>
+                <a:lnTo>
+                  <a:pt x="290935" y="151927"/>
+                </a:lnTo>
+                <a:lnTo>
+                  <a:pt x="307713" y="151927"/>
+                </a:lnTo>
+                <a:lnTo>
+                  <a:pt x="299059" y="192360"/>
+                </a:lnTo>
+                <a:lnTo>
+                  <a:pt x="325227" y="192360"/>
+                </a:lnTo>
+                <a:lnTo>
+                  <a:pt x="333779" y="151927"/>
+                </a:lnTo>
+                <a:lnTo>
+                  <a:pt x="348933" y="151927"/>
+                </a:lnTo>
+                <a:cubicBezTo>
+                  <a:pt x="348334" y="164464"/>
+                  <a:pt x="351533" y="175872"/>
+                  <a:pt x="359845" y="183517"/>
+                </a:cubicBezTo>
+                <a:cubicBezTo>
+                  <a:pt x="370004" y="192839"/>
+                  <a:pt x="385603" y="194617"/>
+                  <a:pt x="397131" y="194617"/>
+                </a:cubicBezTo>
+                <a:cubicBezTo>
+                  <a:pt x="413526" y="194421"/>
+                  <a:pt x="429850" y="192418"/>
+                  <a:pt x="445807" y="188648"/>
+                </a:cubicBezTo>
+                <a:lnTo>
+                  <a:pt x="454872" y="151927"/>
+                </a:lnTo>
+                <a:lnTo>
+                  <a:pt x="484786" y="151927"/>
+                </a:lnTo>
+                <a:lnTo>
+                  <a:pt x="484786" y="-89"/>
+                </a:lnTo>
+                <a:close/>
+              </a:path>
+            </a:pathLst>
+          </a:custGeom>
+          <a:solidFill>
+            <a:schemeClr val="bg1"/>
+          </a:solidFill>
+          <a:ln w="1683" cap="flat">
+            <a:noFill/>
+            <a:prstDash val="solid"/>
+            <a:miter/>
+          </a:ln>
+        </p:spPr>
+        <p:txBody>
+          <a:bodyPr rtlCol="0" anchor="ctr"/>
+          <a:lstStyle/>
+          <a:p>
+            <a:endParaRPr lang="en-GB"/>
+          </a:p>
+        </p:txBody>
+      </p:sp>
+    </p:spTree>
+    <p:extLst>
+      <p:ext uri="{BB962C8B-B14F-4D97-AF65-F5344CB8AC3E}">
+        <p14:creationId xmlns:p14="http://schemas.microsoft.com/office/powerpoint/2010/main" val="441450201"/>
+      </p:ext>
+    </p:extLst>
+  </p:cSld>
+  <p:clrMapOvr>
+    <a:masterClrMapping/>
+  </p:clrMapOvr>
+</p:sldLayout>
+</file>
+
 <file path=ppt/slideMasters/slideMaster1.xml><?xml version="1.0" encoding="utf-8"?>
 <p:sldMaster xmlns:a="http://schemas.openxmlformats.org/drawingml/2006/main" xmlns:r="http://schemas.openxmlformats.org/officeDocument/2006/relationships" xmlns:p="http://schemas.openxmlformats.org/presentationml/2006/main">
   <p:cSld>
@@ -2819,7 +4368,7 @@
           </p:cNvGraphicFramePr>
           <p:nvPr userDrawn="1">
             <p:custDataLst>
-              <p:tags r:id="rId7"/>
+              <p:tags r:id="rId8"/>
             </p:custDataLst>
             <p:extLst>
               <p:ext uri="{D42A27DB-BD31-4B8C-83A1-F6EECF244321}">
@@ -2836,12 +4385,12 @@
           <a:graphicData uri="http://schemas.openxmlformats.org/presentationml/2006/ole">
             <mc:AlternateContent xmlns:mc="http://schemas.openxmlformats.org/markup-compatibility/2006">
               <mc:Choice xmlns:v="urn:schemas-microsoft-com:vml" Requires="v">
-                <p:oleObj name="think-cell Slide" r:id="rId9" imgW="592" imgH="591" progId="TCLayout.ActiveDocument.1">
+                <p:oleObj name="think-cell Slide" r:id="rId10" imgW="592" imgH="591" progId="TCLayout.ActiveDocument.1">
                   <p:embed/>
                 </p:oleObj>
               </mc:Choice>
               <mc:Fallback>
-                <p:oleObj name="think-cell Slide" r:id="rId9" imgW="592" imgH="591" progId="TCLayout.ActiveDocument.1">
+                <p:oleObj name="think-cell Slide" r:id="rId10" imgW="592" imgH="591" progId="TCLayout.ActiveDocument.1">
                   <p:embed/>
                   <p:pic>
                     <p:nvPicPr>
@@ -2852,7 +4401,7 @@
                       <p:nvPr/>
                     </p:nvPicPr>
                     <p:blipFill>
-                      <a:blip r:embed="rId10"/>
+                      <a:blip r:embed="rId11"/>
                       <a:stretch/>
                     </p:blipFill>
                     <p:spPr>
@@ -3146,7 +4695,7 @@
           <p:cNvSpPr txBox="1"/>
           <p:nvPr userDrawn="1">
             <p:custDataLst>
-              <p:tags r:id="rId8"/>
+              <p:tags r:id="rId9"/>
             </p:custDataLst>
           </p:nvPr>
         </p:nvSpPr>
@@ -4406,6 +5955,7 @@
     <p:sldLayoutId id="2147483725" r:id="rId3"/>
     <p:sldLayoutId id="2147483726" r:id="rId4"/>
     <p:sldLayoutId id="2147483656" r:id="rId5"/>
+    <p:sldLayoutId id="2147483727" r:id="rId6"/>
   </p:sldLayoutIdLst>
   <p:txStyles>
     <p:titleStyle>
@@ -6332,7 +7882,7 @@
           <a:bodyPr/>
           <a:lstStyle/>
           <a:p>
-            <a:endParaRPr lang="zh-CN" altLang="en-US"/>
+            <a:endParaRPr lang="zh-CN" altLang="en-US" sz="1200"/>
           </a:p>
         </p:txBody>
       </p:sp>
@@ -6382,7 +7932,7 @@
         <p:fade/>
       </p:transition>
     </mc:Choice>
-    <mc:Fallback xmlns="" xmlns:a16="http://schemas.microsoft.com/office/drawing/2014/main">
+    <mc:Fallback xmlns:a16="http://schemas.microsoft.com/office/drawing/2014/main" xmlns="">
       <p:transition spd="med">
         <p:fade/>
       </p:transition>
@@ -6392,6 +7942,139 @@
 </file>
 
 <file path=ppt/slides/slide2.xml><?xml version="1.0" encoding="utf-8"?>
+<p:sld xmlns:a="http://schemas.openxmlformats.org/drawingml/2006/main" xmlns:r="http://schemas.openxmlformats.org/officeDocument/2006/relationships" xmlns:p="http://schemas.openxmlformats.org/presentationml/2006/main">
+  <p:cSld>
+    <p:spTree>
+      <p:nvGrpSpPr>
+        <p:cNvPr id="1" name=""/>
+        <p:cNvGrpSpPr/>
+        <p:nvPr/>
+      </p:nvGrpSpPr>
+      <p:grpSpPr>
+        <a:xfrm>
+          <a:off x="0" y="0"/>
+          <a:ext cx="0" cy="0"/>
+          <a:chOff x="0" y="0"/>
+          <a:chExt cx="0" cy="0"/>
+        </a:xfrm>
+      </p:grpSpPr>
+      <p:sp>
+        <p:nvSpPr>
+          <p:cNvPr id="4" name="Text Placeholder 3">
+            <a:extLst>
+              <a:ext uri="{FF2B5EF4-FFF2-40B4-BE49-F238E27FC236}">
+                <a16:creationId xmlns:a16="http://schemas.microsoft.com/office/drawing/2014/main" id="{0BC63CFC-521D-84A5-437F-A50BD0FF0A52}"/>
+              </a:ext>
+            </a:extLst>
+          </p:cNvPr>
+          <p:cNvSpPr>
+            <a:spLocks noGrp="1"/>
+          </p:cNvSpPr>
+          <p:nvPr>
+            <p:ph type="body" sz="quarter" idx="10"/>
+          </p:nvPr>
+        </p:nvSpPr>
+        <p:spPr>
+          <a:xfrm>
+            <a:off x="1397000" y="1069975"/>
+            <a:ext cx="1400175" cy="1698625"/>
+          </a:xfrm>
+        </p:spPr>
+        <p:txBody>
+          <a:bodyPr/>
+          <a:lstStyle/>
+          <a:p>
+            <a:pPr marL="0" indent="0">
+              <a:buNone/>
+            </a:pPr>
+            <a:r>
+              <a:rPr lang="de-CH" sz="8800" dirty="0"/>
+              <a:t>01</a:t>
+            </a:r>
+          </a:p>
+        </p:txBody>
+      </p:sp>
+      <p:sp>
+        <p:nvSpPr>
+          <p:cNvPr id="5" name="Title 1">
+            <a:extLst>
+              <a:ext uri="{FF2B5EF4-FFF2-40B4-BE49-F238E27FC236}">
+                <a16:creationId xmlns:a16="http://schemas.microsoft.com/office/drawing/2014/main" id="{CA8C0EAE-307F-4716-1F7C-70323364A7D7}"/>
+              </a:ext>
+            </a:extLst>
+          </p:cNvPr>
+          <p:cNvSpPr txBox="1">
+            <a:spLocks/>
+          </p:cNvSpPr>
+          <p:nvPr/>
+        </p:nvSpPr>
+        <p:spPr>
+          <a:xfrm>
+            <a:off x="1397000" y="3020695"/>
+            <a:ext cx="3706843" cy="446469"/>
+          </a:xfrm>
+          <a:prstGeom prst="rect">
+            <a:avLst/>
+          </a:prstGeom>
+        </p:spPr>
+        <p:txBody>
+          <a:bodyPr wrap="square" lIns="0" tIns="0" rIns="0" bIns="0">
+            <a:spAutoFit/>
+          </a:bodyPr>
+          <a:lstStyle>
+            <a:lvl1pPr algn="l" defTabSz="914400" rtl="0" eaLnBrk="1" latinLnBrk="0" hangingPunct="1">
+              <a:lnSpc>
+                <a:spcPct val="70000"/>
+              </a:lnSpc>
+              <a:spcBef>
+                <a:spcPct val="0"/>
+              </a:spcBef>
+              <a:buNone/>
+              <a:defRPr sz="4000" kern="1200">
+                <a:solidFill>
+                  <a:schemeClr val="accent2"/>
+                </a:solidFill>
+                <a:latin typeface="+mj-lt"/>
+                <a:ea typeface="+mj-ea"/>
+                <a:cs typeface="Arial" panose="020B0604020202020204" pitchFamily="34" charset="0"/>
+              </a:defRPr>
+            </a:lvl1pPr>
+          </a:lstStyle>
+          <a:p>
+            <a:r>
+              <a:rPr lang="de-CH" b="1" dirty="0" err="1">
+                <a:solidFill>
+                  <a:schemeClr val="bg1"/>
+                </a:solidFill>
+                <a:latin typeface="Microsoft YaHei UI" panose="020B0503020204020204" pitchFamily="34" charset="-122"/>
+                <a:ea typeface="Microsoft YaHei UI" panose="020B0503020204020204" pitchFamily="34" charset="-122"/>
+              </a:rPr>
+              <a:t>主题</a:t>
+            </a:r>
+            <a:endParaRPr lang="de-CH" b="1" dirty="0">
+              <a:solidFill>
+                <a:schemeClr val="bg1"/>
+              </a:solidFill>
+              <a:latin typeface="Microsoft YaHei UI" panose="020B0503020204020204" pitchFamily="34" charset="-122"/>
+              <a:ea typeface="Microsoft YaHei UI" panose="020B0503020204020204" pitchFamily="34" charset="-122"/>
+            </a:endParaRPr>
+          </a:p>
+        </p:txBody>
+      </p:sp>
+    </p:spTree>
+    <p:extLst>
+      <p:ext uri="{BB962C8B-B14F-4D97-AF65-F5344CB8AC3E}">
+        <p14:creationId xmlns:p14="http://schemas.microsoft.com/office/powerpoint/2010/main" val="2264793716"/>
+      </p:ext>
+    </p:extLst>
+  </p:cSld>
+  <p:clrMapOvr>
+    <a:masterClrMapping/>
+  </p:clrMapOvr>
+</p:sld>
+</file>
+
+<file path=ppt/slides/slide3.xml><?xml version="1.0" encoding="utf-8"?>
 <p:sld xmlns:a="http://schemas.openxmlformats.org/drawingml/2006/main" xmlns:r="http://schemas.openxmlformats.org/officeDocument/2006/relationships" xmlns:p="http://schemas.openxmlformats.org/presentationml/2006/main">
   <p:cSld>
     <p:spTree>
@@ -6471,7 +8154,7 @@
 </p:sld>
 </file>
 
-<file path=ppt/slides/slide3.xml><?xml version="1.0" encoding="utf-8"?>
+<file path=ppt/slides/slide4.xml><?xml version="1.0" encoding="utf-8"?>
 <p:sld xmlns:a="http://schemas.openxmlformats.org/drawingml/2006/main" xmlns:r="http://schemas.openxmlformats.org/officeDocument/2006/relationships" xmlns:p="http://schemas.openxmlformats.org/presentationml/2006/main">
   <p:cSld>
     <p:spTree>
@@ -6576,7 +8259,7 @@
 </p:sld>
 </file>
 
-<file path=ppt/slides/slide4.xml><?xml version="1.0" encoding="utf-8"?>
+<file path=ppt/slides/slide5.xml><?xml version="1.0" encoding="utf-8"?>
 <p:sld xmlns:a="http://schemas.openxmlformats.org/drawingml/2006/main" xmlns:r="http://schemas.openxmlformats.org/officeDocument/2006/relationships" xmlns:p="http://schemas.openxmlformats.org/presentationml/2006/main">
   <p:cSld>
     <p:spTree>
@@ -6593,31 +8276,6 @@
           <a:chExt cx="0" cy="0"/>
         </a:xfrm>
       </p:grpSpPr>
-      <p:sp>
-        <p:nvSpPr>
-          <p:cNvPr id="5" name="aria_slide_body">
-            <a:extLst>
-              <a:ext uri="{FF2B5EF4-FFF2-40B4-BE49-F238E27FC236}">
-                <a16:creationId xmlns:a16="http://schemas.microsoft.com/office/drawing/2014/main" id="{34AB6818-F0E0-1016-AF72-0B8C00508A3E}"/>
-              </a:ext>
-            </a:extLst>
-          </p:cNvPr>
-          <p:cNvSpPr>
-            <a:spLocks noGrp="1"/>
-          </p:cNvSpPr>
-          <p:nvPr>
-            <p:ph type="body" sz="quarter" idx="10"/>
-          </p:nvPr>
-        </p:nvSpPr>
-        <p:spPr/>
-        <p:txBody>
-          <a:bodyPr/>
-          <a:lstStyle/>
-          <a:p>
-            <a:endParaRPr lang="zh-CN" altLang="en-US"/>
-          </a:p>
-        </p:txBody>
-      </p:sp>
       <p:sp>
         <p:nvSpPr>
           <p:cNvPr id="4" name="aria_slide_title">
@@ -6719,7 +8377,7 @@
 </p:sld>
 </file>
 
-<file path=ppt/slides/slide5.xml><?xml version="1.0" encoding="utf-8"?>
+<file path=ppt/slides/slide6.xml><?xml version="1.0" encoding="utf-8"?>
 <p:sld xmlns:a="http://schemas.openxmlformats.org/drawingml/2006/main" xmlns:r="http://schemas.openxmlformats.org/officeDocument/2006/relationships" xmlns:p="http://schemas.openxmlformats.org/presentationml/2006/main">
   <p:cSld>
     <p:spTree>
@@ -7190,6 +8848,12 @@
 </file>
 
 <file path=ppt/tags/tag5.xml><?xml version="1.0" encoding="utf-8"?>
+<p:tagLst xmlns:a="http://schemas.openxmlformats.org/drawingml/2006/main" xmlns:r="http://schemas.openxmlformats.org/officeDocument/2006/relationships" xmlns:p="http://schemas.openxmlformats.org/presentationml/2006/main">
+  <p:tag name="DOCUMENTCLASSIFICATION" val="TRUE"/>
+</p:tagLst>
+</file>
+
+<file path=ppt/tags/tag6.xml><?xml version="1.0" encoding="utf-8"?>
 <p:tagLst xmlns:a="http://schemas.openxmlformats.org/drawingml/2006/main" xmlns:r="http://schemas.openxmlformats.org/officeDocument/2006/relationships" xmlns:p="http://schemas.openxmlformats.org/presentationml/2006/main">
   <p:tag name="COPYRIGHT1" val="TRUE"/>
 </p:tagLst>

</xml_diff>

<commit_message>
Route digital strategy pages to revised template
</commit_message>
<xml_diff>
--- a/AriaAI/skills/digital-strategy/assets/Template.pptx
+++ b/AriaAI/skills/digital-strategy/assets/Template.pptx
@@ -747,7 +747,7 @@
         <p:fade/>
       </p:transition>
     </mc:Choice>
-    <mc:Fallback xmlns:p15="http://schemas.microsoft.com/office/powerpoint/2012/main" xmlns:a14="http://schemas.microsoft.com/office/drawing/2010/main" xmlns:a16="http://schemas.microsoft.com/office/drawing/2014/main" xmlns="">
+    <mc:Fallback xmlns="" xmlns:a16="http://schemas.microsoft.com/office/drawing/2014/main" xmlns:a14="http://schemas.microsoft.com/office/drawing/2010/main" xmlns:p15="http://schemas.microsoft.com/office/powerpoint/2012/main">
       <p:transition spd="med">
         <p:fade/>
       </p:transition>
@@ -7882,7 +7882,10 @@
           <a:bodyPr/>
           <a:lstStyle/>
           <a:p>
-            <a:endParaRPr lang="zh-CN" altLang="en-US" sz="1200"/>
+            <a:pPr marL="0" indent="0">
+              <a:buNone/>
+            </a:pPr>
+            <a:endParaRPr lang="zh-CN" altLang="en-US" sz="1200" dirty="0"/>
           </a:p>
         </p:txBody>
       </p:sp>
@@ -7912,7 +7915,7 @@
           <a:bodyPr/>
           <a:lstStyle/>
           <a:p>
-            <a:endParaRPr lang="zh-CN" altLang="en-US"/>
+            <a:endParaRPr lang="zh-CN" altLang="en-US" dirty="0"/>
           </a:p>
         </p:txBody>
       </p:sp>
@@ -7932,7 +7935,7 @@
         <p:fade/>
       </p:transition>
     </mc:Choice>
-    <mc:Fallback xmlns:a16="http://schemas.microsoft.com/office/drawing/2014/main" xmlns="">
+    <mc:Fallback xmlns="" xmlns:a16="http://schemas.microsoft.com/office/drawing/2014/main">
       <p:transition spd="med">
         <p:fade/>
       </p:transition>
@@ -7960,7 +7963,7 @@
       </p:grpSpPr>
       <p:sp>
         <p:nvSpPr>
-          <p:cNvPr id="4" name="Text Placeholder 3">
+          <p:cNvPr id="4" name="aria_section_number">
             <a:extLst>
               <a:ext uri="{FF2B5EF4-FFF2-40B4-BE49-F238E27FC236}">
                 <a16:creationId xmlns:a16="http://schemas.microsoft.com/office/drawing/2014/main" id="{0BC63CFC-521D-84A5-437F-A50BD0FF0A52}"/>
@@ -7988,7 +7991,7 @@
               <a:buNone/>
             </a:pPr>
             <a:r>
-              <a:rPr lang="de-CH" sz="8800" dirty="0"/>
+              <a:rPr lang="zh-CN" sz="8800" dirty="0"/>
               <a:t>01</a:t>
             </a:r>
           </a:p>
@@ -7996,7 +7999,7 @@
       </p:sp>
       <p:sp>
         <p:nvSpPr>
-          <p:cNvPr id="5" name="Title 1">
+          <p:cNvPr id="5" name="aria_section_title">
             <a:extLst>
               <a:ext uri="{FF2B5EF4-FFF2-40B4-BE49-F238E27FC236}">
                 <a16:creationId xmlns:a16="http://schemas.microsoft.com/office/drawing/2014/main" id="{CA8C0EAE-307F-4716-1F7C-70323364A7D7}"/>
@@ -8010,8 +8013,8 @@
         </p:nvSpPr>
         <p:spPr>
           <a:xfrm>
-            <a:off x="1397000" y="3020695"/>
-            <a:ext cx="3706843" cy="446469"/>
+            <a:off x="1397001" y="3020695"/>
+            <a:ext cx="2312358" cy="446469"/>
           </a:xfrm>
           <a:prstGeom prst="rect">
             <a:avLst/>
@@ -8042,7 +8045,7 @@
           </a:lstStyle>
           <a:p>
             <a:r>
-              <a:rPr lang="de-CH" b="1" dirty="0" err="1">
+              <a:rPr lang="zh-CN" b="1" dirty="0">
                 <a:solidFill>
                   <a:schemeClr val="bg1"/>
                 </a:solidFill>
@@ -8051,13 +8054,6 @@
               </a:rPr>
               <a:t>主题</a:t>
             </a:r>
-            <a:endParaRPr lang="de-CH" b="1" dirty="0">
-              <a:solidFill>
-                <a:schemeClr val="bg1"/>
-              </a:solidFill>
-              <a:latin typeface="Microsoft YaHei UI" panose="020B0503020204020204" pitchFamily="34" charset="-122"/>
-              <a:ea typeface="Microsoft YaHei UI" panose="020B0503020204020204" pitchFamily="34" charset="-122"/>
-            </a:endParaRPr>
           </a:p>
         </p:txBody>
       </p:sp>
@@ -8298,69 +8294,6 @@
           <a:lstStyle/>
           <a:p>
             <a:endParaRPr lang="zh-CN" altLang="en-US" dirty="0"/>
-          </a:p>
-        </p:txBody>
-      </p:sp>
-      <p:sp>
-        <p:nvSpPr>
-          <p:cNvPr id="6" name="aria_visual_area">
-            <a:extLst>
-              <a:ext uri="{FF2B5EF4-FFF2-40B4-BE49-F238E27FC236}">
-                <a16:creationId xmlns:a16="http://schemas.microsoft.com/office/drawing/2014/main" id="{0F001D15-8E9F-729D-F3D8-89F3AB735796}"/>
-              </a:ext>
-            </a:extLst>
-          </p:cNvPr>
-          <p:cNvSpPr/>
-          <p:nvPr/>
-        </p:nvSpPr>
-        <p:spPr>
-          <a:xfrm>
-            <a:off x="6385560" y="1295400"/>
-            <a:ext cx="5532120" cy="4602480"/>
-          </a:xfrm>
-          <a:prstGeom prst="rect">
-            <a:avLst/>
-          </a:prstGeom>
-          <a:noFill/>
-          <a:ln>
-            <a:solidFill>
-              <a:schemeClr val="bg1">
-                <a:lumMod val="95000"/>
-              </a:schemeClr>
-            </a:solidFill>
-          </a:ln>
-        </p:spPr>
-        <p:style>
-          <a:lnRef idx="2">
-            <a:schemeClr val="accent1">
-              <a:shade val="50000"/>
-            </a:schemeClr>
-          </a:lnRef>
-          <a:fillRef idx="1">
-            <a:schemeClr val="accent1"/>
-          </a:fillRef>
-          <a:effectRef idx="0">
-            <a:schemeClr val="accent1"/>
-          </a:effectRef>
-          <a:fontRef idx="minor">
-            <a:schemeClr val="lt1"/>
-          </a:fontRef>
-        </p:style>
-        <p:txBody>
-          <a:bodyPr rot="0" spcFirstLastPara="0" vertOverflow="overflow" horzOverflow="overflow" vert="horz" wrap="square" lIns="54610" tIns="54610" rIns="54610" bIns="54610" numCol="1" spcCol="0" rtlCol="0" fromWordArt="0" anchor="ctr" anchorCtr="0" forceAA="0" compatLnSpc="1">
-            <a:prstTxWarp prst="textNoShape">
-              <a:avLst/>
-            </a:prstTxWarp>
-            <a:noAutofit/>
-          </a:bodyPr>
-          <a:lstStyle/>
-          <a:p>
-            <a:pPr algn="l"/>
-            <a:endParaRPr kumimoji="1" lang="zh-CN" altLang="en-US" sz="1600" dirty="0">
-              <a:solidFill>
-                <a:schemeClr val="bg1"/>
-              </a:solidFill>
-            </a:endParaRPr>
           </a:p>
         </p:txBody>
       </p:sp>

</xml_diff>

<commit_message>
Preserve template runs for digital strategy deck
</commit_message>
<xml_diff>
--- a/AriaAI/skills/digital-strategy/assets/Template.pptx
+++ b/AriaAI/skills/digital-strategy/assets/Template.pptx
@@ -747,7 +747,7 @@
         <p:fade/>
       </p:transition>
     </mc:Choice>
-    <mc:Fallback xmlns="" xmlns:a16="http://schemas.microsoft.com/office/drawing/2014/main" xmlns:a14="http://schemas.microsoft.com/office/drawing/2010/main" xmlns:p15="http://schemas.microsoft.com/office/powerpoint/2012/main">
+    <mc:Fallback xmlns:p15="http://schemas.microsoft.com/office/powerpoint/2012/main" xmlns:a14="http://schemas.microsoft.com/office/drawing/2010/main" xmlns:a16="http://schemas.microsoft.com/office/drawing/2014/main" xmlns="">
       <p:transition spd="med">
         <p:fade/>
       </p:transition>
@@ -7935,7 +7935,7 @@
         <p:fade/>
       </p:transition>
     </mc:Choice>
-    <mc:Fallback xmlns="" xmlns:a16="http://schemas.microsoft.com/office/drawing/2014/main">
+    <mc:Fallback xmlns:a16="http://schemas.microsoft.com/office/drawing/2014/main" xmlns="">
       <p:transition spd="med">
         <p:fade/>
       </p:transition>
@@ -8133,7 +8133,10 @@
           <a:bodyPr/>
           <a:lstStyle/>
           <a:p>
-            <a:endParaRPr kumimoji="1" lang="zh-CN" altLang="en-US" dirty="0"/>
+            <a:endParaRPr kumimoji="1" lang="zh-CN" altLang="en-US" sz="3600" b="1" dirty="0">
+              <a:latin typeface="Microsoft YaHei UI" panose="020B0503020204020204" pitchFamily="34" charset="-122"/>
+              <a:ea typeface="Microsoft YaHei UI" panose="020B0503020204020204" pitchFamily="34" charset="-122"/>
+            </a:endParaRPr>
           </a:p>
         </p:txBody>
       </p:sp>
@@ -8235,10 +8238,13 @@
         </p:nvSpPr>
         <p:spPr/>
         <p:txBody>
-          <a:bodyPr/>
+          <a:bodyPr vert="horz" lIns="0" tIns="0" rIns="0" bIns="0" anchor="t" anchorCtr="0"/>
           <a:lstStyle/>
           <a:p>
-            <a:endParaRPr lang="zh-CN" altLang="en-US"/>
+            <a:endParaRPr kumimoji="1" lang="zh-CN" altLang="en-US" sz="3600" b="1">
+              <a:latin typeface="Microsoft YaHei UI" panose="020B0503020204020204" pitchFamily="34" charset="-122"/>
+              <a:ea typeface="Microsoft YaHei UI" panose="020B0503020204020204" pitchFamily="34" charset="-122"/>
+            </a:endParaRPr>
           </a:p>
         </p:txBody>
       </p:sp>
@@ -8290,10 +8296,13 @@
         </p:nvSpPr>
         <p:spPr/>
         <p:txBody>
-          <a:bodyPr/>
+          <a:bodyPr vert="horz" lIns="0" tIns="0" rIns="0" bIns="0" anchor="t" anchorCtr="0"/>
           <a:lstStyle/>
           <a:p>
-            <a:endParaRPr lang="zh-CN" altLang="en-US" dirty="0"/>
+            <a:endParaRPr kumimoji="1" lang="zh-CN" altLang="en-US" sz="3600" b="1" dirty="0">
+              <a:latin typeface="Microsoft YaHei UI" panose="020B0503020204020204" pitchFamily="34" charset="-122"/>
+              <a:ea typeface="Microsoft YaHei UI" panose="020B0503020204020204" pitchFamily="34" charset="-122"/>
+            </a:endParaRPr>
           </a:p>
         </p:txBody>
       </p:sp>

</xml_diff>